<commit_message>
fix(defense-ppt): CJK font — 한글 깨짐 해결
Docker LibreOffice 가 "맑은 고딕" 을 찾지 못해 PDF 변환 시 모든 한글이
tofu 박스로 렌더링되던 문제. 폰트명을 "Noto Sans CJK KR" 로 변경:

- 리눅스 컨테이너 (fonts-noto-cjk 설치됨) 에서 정상 렌더링 → PDF OK
- Windows PowerPoint 는 "Noto Sans CJK KR" 없으면 맑은 고딕으로 자동 fallback
  → PPTX 원본도 그대로 OK

PDF 파일 크기: 330 KB → 461 KB (폰트 embed 확인).

Co-Authored-By: Claude Opus 4.7 (1M context) <noreply@anthropic.com>
</commit_message>
<xml_diff>
--- a/thesis_current/박사논문_방어발표_v1.pptx
+++ b/thesis_current/박사논문_방어발표_v1.pptx
@@ -3192,7 +3192,7 @@
                 <a:solidFill>
                   <a:srgbClr val="FFFFFF"/>
                 </a:solidFill>
-                <a:latin typeface="맑은 고딕"/>
+                <a:latin typeface="Noto Sans CJK KR"/>
               </a:rPr>
               <a:t>호서대학교 대학원</a:t>
             </a:r>
@@ -3227,7 +3227,7 @@
                 <a:solidFill>
                   <a:srgbClr val="FFFFFF"/>
                 </a:solidFill>
-                <a:latin typeface="맑은 고딕"/>
+                <a:latin typeface="Noto Sans CJK KR"/>
               </a:rPr>
               <a:t>융합공학과</a:t>
             </a:r>
@@ -3262,7 +3262,7 @@
                 <a:solidFill>
                   <a:srgbClr val="FFFFFF"/>
                 </a:solidFill>
-                <a:latin typeface="맑은 고딕"/>
+                <a:latin typeface="Noto Sans CJK KR"/>
               </a:rPr>
               <a:t>박사학위 논문 방어 발표</a:t>
             </a:r>
@@ -3297,7 +3297,7 @@
                 <a:solidFill>
                   <a:srgbClr val="FFFFFF"/>
                 </a:solidFill>
-                <a:latin typeface="맑은 고딕"/>
+                <a:latin typeface="Noto Sans CJK KR"/>
               </a:rPr>
               <a:t>2026. 4. 30.</a:t>
             </a:r>
@@ -3332,7 +3332,7 @@
                 <a:solidFill>
                   <a:srgbClr val="6B7280"/>
                 </a:solidFill>
-                <a:latin typeface="맑은 고딕"/>
+                <a:latin typeface="Noto Sans CJK KR"/>
               </a:rPr>
               <a:t>박사학위 논문</a:t>
             </a:r>
@@ -3367,7 +3367,7 @@
                 <a:solidFill>
                   <a:srgbClr val="1E3A8A"/>
                 </a:solidFill>
-                <a:latin typeface="맑은 고딕"/>
+                <a:latin typeface="Noto Sans CJK KR"/>
               </a:rPr>
               <a:t>근위 정책 최적화 기반 적응형</a:t>
             </a:r>
@@ -3379,7 +3379,7 @@
                 <a:solidFill>
                   <a:srgbClr val="1E3A8A"/>
                 </a:solidFill>
-                <a:latin typeface="맑은 고딕"/>
+                <a:latin typeface="Noto Sans CJK KR"/>
               </a:rPr>
               <a:t>동적 가중치 학습을 통한</a:t>
             </a:r>
@@ -3391,7 +3391,7 @@
                 <a:solidFill>
                   <a:srgbClr val="1E3A8A"/>
                 </a:solidFill>
-                <a:latin typeface="맑은 고딕"/>
+                <a:latin typeface="Noto Sans CJK KR"/>
               </a:rPr>
               <a:t>Triple-Hybrid RAG 프레임워크의</a:t>
             </a:r>
@@ -3403,7 +3403,7 @@
                 <a:solidFill>
                   <a:srgbClr val="1E3A8A"/>
                 </a:solidFill>
-                <a:latin typeface="맑은 고딕"/>
+                <a:latin typeface="Noto Sans CJK KR"/>
               </a:rPr>
               <a:t>성능 최적화 연구</a:t>
             </a:r>
@@ -3485,7 +3485,7 @@
                 <a:solidFill>
                   <a:srgbClr val="1E293B"/>
                 </a:solidFill>
-                <a:latin typeface="맑은 고딕"/>
+                <a:latin typeface="Noto Sans CJK KR"/>
               </a:rPr>
               <a:t>발표자: 신동욱 (Shin Dong-wook)</a:t>
             </a:r>
@@ -3520,7 +3520,7 @@
                 <a:solidFill>
                   <a:srgbClr val="1E293B"/>
                 </a:solidFill>
-                <a:latin typeface="맑은 고딕"/>
+                <a:latin typeface="Noto Sans CJK KR"/>
               </a:rPr>
               <a:t>지도교수: 문남미 (Prof. Nammee Moon)</a:t>
             </a:r>
@@ -3624,7 +3624,7 @@
                 <a:solidFill>
                   <a:srgbClr val="1E3A8A"/>
                 </a:solidFill>
-                <a:latin typeface="맑은 고딕"/>
+                <a:latin typeface="Noto Sans CJK KR"/>
               </a:rPr>
               <a:t>학습 — PPO (Proximal Policy Optimization)</a:t>
             </a:r>
@@ -3737,7 +3737,7 @@
                 <a:solidFill>
                   <a:srgbClr val="1E3A8A"/>
                 </a:solidFill>
-                <a:latin typeface="맑은 고딕"/>
+                <a:latin typeface="Noto Sans CJK KR"/>
               </a:rPr>
               <a:t>학습 알고리즘</a:t>
             </a:r>
@@ -3772,7 +3772,7 @@
                 <a:solidFill>
                   <a:srgbClr val="1E293B"/>
                 </a:solidFill>
-                <a:latin typeface="맑은 고딕"/>
+                <a:latin typeface="Noto Sans CJK KR"/>
               </a:rPr>
               <a:t>• OpenAI 2017, ChatGPT RLHF 에도 사용</a:t>
             </a:r>
@@ -3784,7 +3784,7 @@
                 <a:solidFill>
                   <a:srgbClr val="1E293B"/>
                 </a:solidFill>
-                <a:latin typeface="맑은 고딕"/>
+                <a:latin typeface="Noto Sans CJK KR"/>
               </a:rPr>
               <a:t>• clip ratio = 0.2 (정책 업데이트 폭 제한)</a:t>
             </a:r>
@@ -3796,7 +3796,7 @@
                 <a:solidFill>
                   <a:srgbClr val="1E293B"/>
                 </a:solidFill>
-                <a:latin typeface="맑은 고딕"/>
+                <a:latin typeface="Noto Sans CJK KR"/>
               </a:rPr>
               <a:t>• GAE λ = 0.95</a:t>
             </a:r>
@@ -3808,7 +3808,7 @@
                 <a:solidFill>
                   <a:srgbClr val="1E293B"/>
                 </a:solidFill>
-                <a:latin typeface="맑은 고딕"/>
+                <a:latin typeface="Noto Sans CJK KR"/>
               </a:rPr>
               <a:t>• Entropy coef = 0.01 (탐색 유지)</a:t>
             </a:r>
@@ -3820,7 +3820,7 @@
                 <a:solidFill>
                   <a:srgbClr val="1E293B"/>
                 </a:solidFill>
-                <a:latin typeface="맑은 고딕"/>
+                <a:latin typeface="Noto Sans CJK KR"/>
               </a:rPr>
               <a:t>• Total episodes = 10,000</a:t>
             </a:r>
@@ -3832,7 +3832,7 @@
                 <a:solidFill>
                   <a:srgbClr val="1E293B"/>
                 </a:solidFill>
-                <a:latin typeface="맑은 고딕"/>
+                <a:latin typeface="Noto Sans CJK KR"/>
               </a:rPr>
               <a:t>• 3 random seeds: 42, 123, 999</a:t>
             </a:r>
@@ -3867,7 +3867,7 @@
                 <a:solidFill>
                   <a:srgbClr val="1E3A8A"/>
                 </a:solidFill>
-                <a:latin typeface="맑은 고딕"/>
+                <a:latin typeface="Noto Sans CJK KR"/>
               </a:rPr>
               <a:t>3-seed 표준편차 &lt; 1% — 학습 자체의 재현성 확보.</a:t>
             </a:r>
@@ -3945,7 +3945,7 @@
                 <a:solidFill>
                   <a:srgbClr val="6B7280"/>
                 </a:solidFill>
-                <a:latin typeface="맑은 고딕"/>
+                <a:latin typeface="Noto Sans CJK KR"/>
               </a:rPr>
               <a:t>신동욱 (Shin Dong-wook) · 호서대학교 대학원 융합공학과 · 박사학위 방어 발표</a:t>
             </a:r>
@@ -3980,7 +3980,7 @@
                 <a:solidFill>
                   <a:srgbClr val="6B7280"/>
                 </a:solidFill>
-                <a:latin typeface="맑은 고딕"/>
+                <a:latin typeface="Noto Sans CJK KR"/>
               </a:rPr>
               <a:t>10 / 26</a:t>
             </a:r>
@@ -4015,7 +4015,7 @@
                 <a:solidFill>
                   <a:srgbClr val="1E3A8A"/>
                 </a:solidFill>
-                <a:latin typeface="맑은 고딕"/>
+                <a:latin typeface="Noto Sans CJK KR"/>
               </a:rPr>
               <a:t>Part B — 문제와 방법</a:t>
             </a:r>
@@ -4119,7 +4119,7 @@
                 <a:solidFill>
                   <a:srgbClr val="1E3A8A"/>
                 </a:solidFill>
-                <a:latin typeface="맑은 고딕"/>
+                <a:latin typeface="Noto Sans CJK KR"/>
               </a:rPr>
               <a:t>오프라인 보상 캐시 — 비용 병목 해소</a:t>
             </a:r>
@@ -4232,7 +4232,7 @@
                 <a:solidFill>
                   <a:srgbClr val="E8756E"/>
                 </a:solidFill>
-                <a:latin typeface="맑은 고딕"/>
+                <a:latin typeface="Noto Sans CJK KR"/>
               </a:rPr>
               <a:t>문제: Naive PPO 는 매 에피소드 LLM 호출 필요</a:t>
             </a:r>
@@ -4267,7 +4267,7 @@
                 <a:solidFill>
                   <a:srgbClr val="1E293B"/>
                 </a:solidFill>
-                <a:latin typeface="맑은 고딕"/>
+                <a:latin typeface="Noto Sans CJK KR"/>
               </a:rPr>
               <a:t>• 10,000 ep × 3 seed × 32 rollout</a:t>
             </a:r>
@@ -4279,7 +4279,7 @@
                 <a:solidFill>
                   <a:srgbClr val="1E293B"/>
                 </a:solidFill>
-                <a:latin typeface="맑은 고딕"/>
+                <a:latin typeface="Noto Sans CJK KR"/>
               </a:rPr>
               <a:t>  = 약 1M LLM 호출</a:t>
             </a:r>
@@ -4291,7 +4291,7 @@
                 <a:solidFill>
                   <a:srgbClr val="1E293B"/>
                 </a:solidFill>
-                <a:latin typeface="맑은 고딕"/>
+                <a:latin typeface="Noto Sans CJK KR"/>
               </a:rPr>
               <a:t>• gpt-4o-mini 단가: ≈ $288</a:t>
             </a:r>
@@ -4303,7 +4303,7 @@
                 <a:solidFill>
                   <a:srgbClr val="1E293B"/>
                 </a:solidFill>
-                <a:latin typeface="맑은 고딕"/>
+                <a:latin typeface="Noto Sans CJK KR"/>
               </a:rPr>
               <a:t>• 개인 연구자가 반복 실험 불가</a:t>
             </a:r>
@@ -4338,7 +4338,7 @@
                 <a:solidFill>
                   <a:srgbClr val="8FB573"/>
                 </a:solidFill>
-                <a:latin typeface="맑은 고딕"/>
+                <a:latin typeface="Noto Sans CJK KR"/>
               </a:rPr>
               <a:t>해결: 보상을 미리 전부 계산</a:t>
             </a:r>
@@ -4373,7 +4373,7 @@
                 <a:solidFill>
                   <a:srgbClr val="1E293B"/>
                 </a:solidFill>
-                <a:latin typeface="맑은 고딕"/>
+                <a:latin typeface="Noto Sans CJK KR"/>
               </a:rPr>
               <a:t>① 5,000 질의 × 66 이산 조합 = 330,000 엔트리</a:t>
             </a:r>
@@ -4385,7 +4385,7 @@
                 <a:solidFill>
                   <a:srgbClr val="1E293B"/>
                 </a:solidFill>
-                <a:latin typeface="맑은 고딕"/>
+                <a:latin typeface="Noto Sans CJK KR"/>
               </a:rPr>
               <a:t>② (α, β, γ) → (F1, EM, Faith, latency) 를 SQLite 에 저장</a:t>
             </a:r>
@@ -4397,7 +4397,7 @@
                 <a:solidFill>
                   <a:srgbClr val="1E293B"/>
                 </a:solidFill>
-                <a:latin typeface="맑은 고딕"/>
+                <a:latin typeface="Noto Sans CJK KR"/>
               </a:rPr>
               <a:t>③ 이후 PPO 학습은 조회만 — LLM 호출 0 회</a:t>
             </a:r>
@@ -4409,7 +4409,7 @@
                 <a:solidFill>
                   <a:srgbClr val="1E293B"/>
                 </a:solidFill>
-                <a:latin typeface="맑은 고딕"/>
+                <a:latin typeface="Noto Sans CJK KR"/>
               </a:rPr>
               <a:t/>
             </a:r>
@@ -4421,7 +4421,7 @@
                 <a:solidFill>
                   <a:srgbClr val="1E293B"/>
                 </a:solidFill>
-                <a:latin typeface="맑은 고딕"/>
+                <a:latin typeface="Noto Sans CJK KR"/>
               </a:rPr>
               <a:t>캐시 구축 1회: $33 · 14시간</a:t>
             </a:r>
@@ -4433,7 +4433,7 @@
                 <a:solidFill>
                   <a:srgbClr val="1E293B"/>
                 </a:solidFill>
-                <a:latin typeface="맑은 고딕"/>
+                <a:latin typeface="Noto Sans CJK KR"/>
               </a:rPr>
               <a:t>이후 3-seed 학습: 5시간 · $0</a:t>
             </a:r>
@@ -4445,7 +4445,7 @@
                 <a:solidFill>
                   <a:srgbClr val="1E293B"/>
                 </a:solidFill>
-                <a:latin typeface="맑은 고딕"/>
+                <a:latin typeface="Noto Sans CJK KR"/>
               </a:rPr>
               <a:t>→ 총 비용 −85% 절감</a:t>
             </a:r>
@@ -4500,7 +4500,7 @@
                 <a:solidFill>
                   <a:srgbClr val="1E3A8A"/>
                 </a:solidFill>
-                <a:latin typeface="맑은 고딕"/>
+                <a:latin typeface="Noto Sans CJK KR"/>
               </a:rPr>
               <a:t>비용 구조 비교</a:t>
             </a:r>
@@ -4512,7 +4512,7 @@
                 <a:solidFill>
                   <a:srgbClr val="1E293B"/>
                 </a:solidFill>
-                <a:latin typeface="맑은 고딕"/>
+                <a:latin typeface="Noto Sans CJK KR"/>
               </a:rPr>
               <a:t>              Naive PPO         Cache + PPO</a:t>
             </a:r>
@@ -4524,7 +4524,7 @@
                 <a:solidFill>
                   <a:srgbClr val="1E293B"/>
                 </a:solidFill>
-                <a:latin typeface="맑은 고딕"/>
+                <a:latin typeface="Noto Sans CJK KR"/>
               </a:rPr>
               <a:t>─────────────────────────────────────</a:t>
             </a:r>
@@ -4536,7 +4536,7 @@
                 <a:solidFill>
                   <a:srgbClr val="1E293B"/>
                 </a:solidFill>
-                <a:latin typeface="맑은 고딕"/>
+                <a:latin typeface="Noto Sans CJK KR"/>
               </a:rPr>
               <a:t>LLM 호출       ~1,000,000          330,000 (1회)</a:t>
             </a:r>
@@ -4548,7 +4548,7 @@
                 <a:solidFill>
                   <a:srgbClr val="1E293B"/>
                 </a:solidFill>
-                <a:latin typeface="맑은 고딕"/>
+                <a:latin typeface="Noto Sans CJK KR"/>
               </a:rPr>
               <a:t>학습 호출      10,000,000+                  0</a:t>
             </a:r>
@@ -4560,7 +4560,7 @@
                 <a:solidFill>
                   <a:srgbClr val="1E293B"/>
                 </a:solidFill>
-                <a:latin typeface="맑은 고딕"/>
+                <a:latin typeface="Noto Sans CJK KR"/>
               </a:rPr>
               <a:t>총 LLM 비용        $288                    $33</a:t>
             </a:r>
@@ -4572,7 +4572,7 @@
                 <a:solidFill>
                   <a:srgbClr val="1E293B"/>
                 </a:solidFill>
-                <a:latin typeface="맑은 고딕"/>
+                <a:latin typeface="Noto Sans CJK KR"/>
               </a:rPr>
               <a:t>wall-clock         50 h+                  19 h</a:t>
             </a:r>
@@ -4584,7 +4584,7 @@
                 <a:solidFill>
                   <a:srgbClr val="1E293B"/>
                 </a:solidFill>
-                <a:latin typeface="맑은 고딕"/>
+                <a:latin typeface="Noto Sans CJK KR"/>
               </a:rPr>
               <a:t>재학습 비용      매번 $288             매번 $0</a:t>
             </a:r>
@@ -4619,7 +4619,7 @@
                 <a:solidFill>
                   <a:srgbClr val="1E3A8A"/>
                 </a:solidFill>
-                <a:latin typeface="맑은 고딕"/>
+                <a:latin typeface="Noto Sans CJK KR"/>
               </a:rPr>
               <a:t>→ 이 엔지니어링 선택이 개인 연구자 수준의</a:t>
             </a:r>
@@ -4631,7 +4631,7 @@
                 <a:solidFill>
                   <a:srgbClr val="1E3A8A"/>
                 </a:solidFill>
-                <a:latin typeface="맑은 고딕"/>
+                <a:latin typeface="Noto Sans CJK KR"/>
               </a:rPr>
               <a:t>   반복 가능성을 만들어 주었다.</a:t>
             </a:r>
@@ -4709,7 +4709,7 @@
                 <a:solidFill>
                   <a:srgbClr val="6B7280"/>
                 </a:solidFill>
-                <a:latin typeface="맑은 고딕"/>
+                <a:latin typeface="Noto Sans CJK KR"/>
               </a:rPr>
               <a:t>신동욱 (Shin Dong-wook) · 호서대학교 대학원 융합공학과 · 박사학위 방어 발표</a:t>
             </a:r>
@@ -4744,7 +4744,7 @@
                 <a:solidFill>
                   <a:srgbClr val="6B7280"/>
                 </a:solidFill>
-                <a:latin typeface="맑은 고딕"/>
+                <a:latin typeface="Noto Sans CJK KR"/>
               </a:rPr>
               <a:t>11 / 26</a:t>
             </a:r>
@@ -4779,7 +4779,7 @@
                 <a:solidFill>
                   <a:srgbClr val="1E3A8A"/>
                 </a:solidFill>
-                <a:latin typeface="맑은 고딕"/>
+                <a:latin typeface="Noto Sans CJK KR"/>
               </a:rPr>
               <a:t>Part B — 문제와 방법</a:t>
             </a:r>
@@ -4883,7 +4883,7 @@
                 <a:solidFill>
                   <a:srgbClr val="1E3A8A"/>
                 </a:solidFill>
-                <a:latin typeface="맑은 고딕"/>
+                <a:latin typeface="Noto Sans CJK KR"/>
               </a:rPr>
               <a:t>재현성 복구 — Stage-wise CORRIGENDUM</a:t>
             </a:r>
@@ -4996,7 +4996,7 @@
                 <a:solidFill>
                   <a:srgbClr val="E8756E"/>
                 </a:solidFill>
-                <a:latin typeface="맑은 고딕"/>
+                <a:latin typeface="Noto Sans CJK KR"/>
               </a:rPr>
               <a:t>선행 JKSCI 2025 의 F1 0.86 이 현 저장소로는 재현 불가</a:t>
             </a:r>
@@ -5074,7 +5074,7 @@
                 <a:solidFill>
                   <a:srgbClr val="FFFFFF"/>
                 </a:solidFill>
-                <a:latin typeface="맑은 고딕"/>
+                <a:latin typeface="Noto Sans CJK KR"/>
               </a:rPr>
               <a:t>S0</a:t>
             </a:r>
@@ -5109,7 +5109,7 @@
                 <a:solidFill>
                   <a:srgbClr val="1E293B"/>
                 </a:solidFill>
-                <a:latin typeface="맑은 고딕"/>
+                <a:latin typeface="Noto Sans CJK KR"/>
               </a:rPr>
               <a:t>JKSCI 원 주장</a:t>
             </a:r>
@@ -5144,7 +5144,7 @@
                 <a:solidFill>
                   <a:srgbClr val="6B7280"/>
                 </a:solidFill>
-                <a:latin typeface="맑은 고딕"/>
+                <a:latin typeface="Noto Sans CJK KR"/>
               </a:rPr>
               <a:t>재현 불가 (CORRIGENDUM §3)</a:t>
             </a:r>
@@ -5179,7 +5179,7 @@
                 <a:solidFill>
                   <a:srgbClr val="6B7280"/>
                 </a:solidFill>
-                <a:latin typeface="맑은 고딕"/>
+                <a:latin typeface="Noto Sans CJK KR"/>
               </a:rPr>
               <a:t>F1 ~0.86</a:t>
             </a:r>
@@ -5257,7 +5257,7 @@
                 <a:solidFill>
                   <a:srgbClr val="FFFFFF"/>
                 </a:solidFill>
-                <a:latin typeface="맑은 고딕"/>
+                <a:latin typeface="Noto Sans CJK KR"/>
               </a:rPr>
               <a:t>S1</a:t>
             </a:r>
@@ -5292,7 +5292,7 @@
                 <a:solidFill>
                   <a:srgbClr val="1E293B"/>
                 </a:solidFill>
-                <a:latin typeface="맑은 고딕"/>
+                <a:latin typeface="Noto Sans CJK KR"/>
               </a:rPr>
               <a:t>`normalize_korean` 구두점 버그 수정</a:t>
             </a:r>
@@ -5327,7 +5327,7 @@
                 <a:solidFill>
                   <a:srgbClr val="6B7280"/>
                 </a:solidFill>
-                <a:latin typeface="맑은 고딕"/>
+                <a:latin typeface="Noto Sans CJK KR"/>
               </a:rPr>
               <a:t>토큰 분리 오류 → +90% 상승</a:t>
             </a:r>
@@ -5362,7 +5362,7 @@
                 <a:solidFill>
                   <a:srgbClr val="1E3A8A"/>
                 </a:solidFill>
-                <a:latin typeface="맑은 고딕"/>
+                <a:latin typeface="Noto Sans CJK KR"/>
               </a:rPr>
               <a:t>F1 0.137</a:t>
             </a:r>
@@ -5440,7 +5440,7 @@
                 <a:solidFill>
                   <a:srgbClr val="FFFFFF"/>
                 </a:solidFill>
-                <a:latin typeface="맑은 고딕"/>
+                <a:latin typeface="Noto Sans CJK KR"/>
               </a:rPr>
               <a:t>S2</a:t>
             </a:r>
@@ -5475,7 +5475,7 @@
                 <a:solidFill>
                   <a:srgbClr val="1E293B"/>
                 </a:solidFill>
-                <a:latin typeface="맑은 고딕"/>
+                <a:latin typeface="Noto Sans CJK KR"/>
               </a:rPr>
               <a:t>`PROMPT_TEMPLATE_LIST` 로 gold 형식 정렬</a:t>
             </a:r>
@@ -5510,7 +5510,7 @@
                 <a:solidFill>
                   <a:srgbClr val="6B7280"/>
                 </a:solidFill>
-                <a:latin typeface="맑은 고딕"/>
+                <a:latin typeface="Noto Sans CJK KR"/>
               </a:rPr>
               <a:t>프롬프트 리스트 형식 → +286%</a:t>
             </a:r>
@@ -5545,7 +5545,7 @@
                 <a:solidFill>
                   <a:srgbClr val="4F86C6"/>
                 </a:solidFill>
-                <a:latin typeface="맑은 고딕"/>
+                <a:latin typeface="Noto Sans CJK KR"/>
               </a:rPr>
               <a:t>F1 0.529</a:t>
             </a:r>
@@ -5623,7 +5623,7 @@
                 <a:solidFill>
                   <a:srgbClr val="FFFFFF"/>
                 </a:solidFill>
-                <a:latin typeface="맑은 고딕"/>
+                <a:latin typeface="Noto Sans CJK KR"/>
               </a:rPr>
               <a:t>S3</a:t>
             </a:r>
@@ -5658,7 +5658,7 @@
                 <a:solidFill>
                   <a:srgbClr val="1E293B"/>
                 </a:solidFill>
-                <a:latin typeface="맑은 고딕"/>
+                <a:latin typeface="Noto Sans CJK KR"/>
               </a:rPr>
               <a:t>`faithfulness()` 2-branch 도입</a:t>
             </a:r>
@@ -5693,7 +5693,7 @@
                 <a:solidFill>
                   <a:srgbClr val="6B7280"/>
                 </a:solidFill>
-                <a:latin typeface="맑은 고딕"/>
+                <a:latin typeface="Noto Sans CJK KR"/>
               </a:rPr>
               <a:t>리스트형 엄격화 (측정 정직성)</a:t>
             </a:r>
@@ -5728,7 +5728,7 @@
                 <a:solidFill>
                   <a:srgbClr val="8FB573"/>
                 </a:solidFill>
-                <a:latin typeface="맑은 고딕"/>
+                <a:latin typeface="Noto Sans CJK KR"/>
               </a:rPr>
               <a:t>F1 0.529</a:t>
             </a:r>
@@ -5763,7 +5763,7 @@
                 <a:solidFill>
                   <a:srgbClr val="1E3A8A"/>
                 </a:solidFill>
-                <a:latin typeface="맑은 고딕"/>
+                <a:latin typeface="Noto Sans CJK KR"/>
               </a:rPr>
               <a:t>본 논문은 S1+S2+S3 적용된 corrected baseline 위에서 L-DWA 의 순수 학습 기여를 측정.</a:t>
             </a:r>
@@ -5841,7 +5841,7 @@
                 <a:solidFill>
                   <a:srgbClr val="6B7280"/>
                 </a:solidFill>
-                <a:latin typeface="맑은 고딕"/>
+                <a:latin typeface="Noto Sans CJK KR"/>
               </a:rPr>
               <a:t>신동욱 (Shin Dong-wook) · 호서대학교 대학원 융합공학과 · 박사학위 방어 발표</a:t>
             </a:r>
@@ -5876,7 +5876,7 @@
                 <a:solidFill>
                   <a:srgbClr val="6B7280"/>
                 </a:solidFill>
-                <a:latin typeface="맑은 고딕"/>
+                <a:latin typeface="Noto Sans CJK KR"/>
               </a:rPr>
               <a:t>12 / 26</a:t>
             </a:r>
@@ -5911,7 +5911,7 @@
                 <a:solidFill>
                   <a:srgbClr val="1E3A8A"/>
                 </a:solidFill>
-                <a:latin typeface="맑은 고딕"/>
+                <a:latin typeface="Noto Sans CJK KR"/>
               </a:rPr>
               <a:t>Part B — 문제와 방법</a:t>
             </a:r>
@@ -6015,7 +6015,7 @@
                 <a:solidFill>
                   <a:srgbClr val="1E3A8A"/>
                 </a:solidFill>
-                <a:latin typeface="맑은 고딕"/>
+                <a:latin typeface="Noto Sans CJK KR"/>
               </a:rPr>
               <a:t>실험 설계</a:t>
             </a:r>
@@ -6148,7 +6148,7 @@
                 <a:solidFill>
                   <a:srgbClr val="1E3A8A"/>
                 </a:solidFill>
-                <a:latin typeface="맑은 고딕"/>
+                <a:latin typeface="Noto Sans CJK KR"/>
               </a:rPr>
               <a:t>📚 벤치마크</a:t>
             </a:r>
@@ -6160,7 +6160,7 @@
                 <a:solidFill>
                   <a:srgbClr val="1E293B"/>
                 </a:solidFill>
-                <a:latin typeface="맑은 고딕"/>
+                <a:latin typeface="Noto Sans CJK KR"/>
               </a:rPr>
               <a:t>합성 대학 코퍼스 (자체 구축)</a:t>
             </a:r>
@@ -6172,7 +6172,7 @@
                 <a:solidFill>
                   <a:srgbClr val="1E293B"/>
                 </a:solidFill>
-                <a:latin typeface="맑은 고딕"/>
+                <a:latin typeface="Noto Sans CJK KR"/>
               </a:rPr>
               <a:t>60 학과 / 577 교수 / 1,505 과목</a:t>
             </a:r>
@@ -6184,7 +6184,7 @@
                 <a:solidFill>
                   <a:srgbClr val="1E293B"/>
                 </a:solidFill>
-                <a:latin typeface="맑은 고딕"/>
+                <a:latin typeface="Noto Sans CJK KR"/>
               </a:rPr>
               <a:t>/ 400 프로젝트 / 2,542 문서</a:t>
             </a:r>
@@ -6196,7 +6196,7 @@
                 <a:solidFill>
                   <a:srgbClr val="1E293B"/>
                 </a:solidFill>
-                <a:latin typeface="맑은 고딕"/>
+                <a:latin typeface="Noto Sans CJK KR"/>
               </a:rPr>
               <a:t>Gold QA: 5,000 쌍</a:t>
             </a:r>
@@ -6208,7 +6208,7 @@
                 <a:solidFill>
                   <a:srgbClr val="1E293B"/>
                 </a:solidFill>
-                <a:latin typeface="맑은 고딕"/>
+                <a:latin typeface="Noto Sans CJK KR"/>
               </a:rPr>
               <a:t>(simple 2,000 / multi_hop 1,750</a:t>
             </a:r>
@@ -6220,7 +6220,7 @@
                 <a:solidFill>
                   <a:srgbClr val="1E293B"/>
                 </a:solidFill>
-                <a:latin typeface="맑은 고딕"/>
+                <a:latin typeface="Noto Sans CJK KR"/>
               </a:rPr>
               <a:t>  / conditional 1,250)</a:t>
             </a:r>
@@ -6275,7 +6275,7 @@
                 <a:solidFill>
                   <a:srgbClr val="1E3A8A"/>
                 </a:solidFill>
-                <a:latin typeface="맑은 고딕"/>
+                <a:latin typeface="Noto Sans CJK KR"/>
               </a:rPr>
               <a:t>🔧 LLM · Embedding</a:t>
             </a:r>
@@ -6287,7 +6287,7 @@
                 <a:solidFill>
                   <a:srgbClr val="1E293B"/>
                 </a:solidFill>
-                <a:latin typeface="맑은 고딕"/>
+                <a:latin typeface="Noto Sans CJK KR"/>
               </a:rPr>
               <a:t>gpt-4o-mini (2024-07-18)</a:t>
             </a:r>
@@ -6299,7 +6299,7 @@
                 <a:solidFill>
                   <a:srgbClr val="1E293B"/>
                 </a:solidFill>
-                <a:latin typeface="맑은 고딕"/>
+                <a:latin typeface="Noto Sans CJK KR"/>
               </a:rPr>
               <a:t>temperature = 0.0</a:t>
             </a:r>
@@ -6311,7 +6311,7 @@
                 <a:solidFill>
                   <a:srgbClr val="1E293B"/>
                 </a:solidFill>
-                <a:latin typeface="맑은 고딕"/>
+                <a:latin typeface="Noto Sans CJK KR"/>
               </a:rPr>
               <a:t>max_tokens = 500</a:t>
             </a:r>
@@ -6323,7 +6323,7 @@
                 <a:solidFill>
                   <a:srgbClr val="1E293B"/>
                 </a:solidFill>
-                <a:latin typeface="맑은 고딕"/>
+                <a:latin typeface="Noto Sans CJK KR"/>
               </a:rPr>
               <a:t>text-embedding-3-small</a:t>
             </a:r>
@@ -6335,7 +6335,7 @@
                 <a:solidFill>
                   <a:srgbClr val="1E293B"/>
                 </a:solidFill>
-                <a:latin typeface="맑은 고딕"/>
+                <a:latin typeface="Noto Sans CJK KR"/>
               </a:rPr>
               <a:t>(1536-dim)</a:t>
             </a:r>
@@ -6347,7 +6347,7 @@
                 <a:solidFill>
                   <a:srgbClr val="1E293B"/>
                 </a:solidFill>
-                <a:latin typeface="맑은 고딕"/>
+                <a:latin typeface="Noto Sans CJK KR"/>
               </a:rPr>
               <a:t>FAISS IndexFlatIP, top-k=3</a:t>
             </a:r>
@@ -6402,7 +6402,7 @@
                 <a:solidFill>
                   <a:srgbClr val="1E3A8A"/>
                 </a:solidFill>
-                <a:latin typeface="맑은 고딕"/>
+                <a:latin typeface="Noto Sans CJK KR"/>
               </a:rPr>
               <a:t>📏 평가 지표</a:t>
             </a:r>
@@ -6414,7 +6414,7 @@
                 <a:solidFill>
                   <a:srgbClr val="1E293B"/>
                 </a:solidFill>
-                <a:latin typeface="맑은 고딕"/>
+                <a:latin typeface="Noto Sans CJK KR"/>
               </a:rPr>
               <a:t>F1_strict (엄격 토큰 F1)</a:t>
             </a:r>
@@ -6426,7 +6426,7 @@
                 <a:solidFill>
                   <a:srgbClr val="1E293B"/>
                 </a:solidFill>
-                <a:latin typeface="맑은 고딕"/>
+                <a:latin typeface="Noto Sans CJK KR"/>
               </a:rPr>
               <a:t>F1_substring (부분 일치 F1)</a:t>
             </a:r>
@@ -6438,7 +6438,7 @@
                 <a:solidFill>
                   <a:srgbClr val="1E293B"/>
                 </a:solidFill>
-                <a:latin typeface="맑은 고딕"/>
+                <a:latin typeface="Noto Sans CJK KR"/>
               </a:rPr>
               <a:t>F1_char (문자 3-gram F1)</a:t>
             </a:r>
@@ -6450,7 +6450,7 @@
                 <a:solidFill>
                   <a:srgbClr val="1E293B"/>
                 </a:solidFill>
-                <a:latin typeface="맑은 고딕"/>
+                <a:latin typeface="Noto Sans CJK KR"/>
               </a:rPr>
               <a:t>EM (Exact Match)</a:t>
             </a:r>
@@ -6462,7 +6462,7 @@
                 <a:solidFill>
                   <a:srgbClr val="1E293B"/>
                 </a:solidFill>
-                <a:latin typeface="맑은 고딕"/>
+                <a:latin typeface="Noto Sans CJK KR"/>
               </a:rPr>
               <a:t>Faithfulness (2-branch)</a:t>
             </a:r>
@@ -6474,7 +6474,7 @@
                 <a:solidFill>
                   <a:srgbClr val="1E293B"/>
                 </a:solidFill>
-                <a:latin typeface="맑은 고딕"/>
+                <a:latin typeface="Noto Sans CJK KR"/>
               </a:rPr>
               <a:t>Latency (seconds)</a:t>
             </a:r>
@@ -6509,7 +6509,7 @@
                 <a:solidFill>
                   <a:srgbClr val="6B7280"/>
                 </a:solidFill>
-                <a:latin typeface="맑은 고딕"/>
+                <a:latin typeface="Noto Sans CJK KR"/>
               </a:rPr>
               <a:t>3 random seeds (42, 123, 999) 평균 보고 · post-CORRIGENDUM 평가기</a:t>
             </a:r>
@@ -6587,7 +6587,7 @@
                 <a:solidFill>
                   <a:srgbClr val="6B7280"/>
                 </a:solidFill>
-                <a:latin typeface="맑은 고딕"/>
+                <a:latin typeface="Noto Sans CJK KR"/>
               </a:rPr>
               <a:t>신동욱 (Shin Dong-wook) · 호서대학교 대학원 융합공학과 · 박사학위 방어 발표</a:t>
             </a:r>
@@ -6622,7 +6622,7 @@
                 <a:solidFill>
                   <a:srgbClr val="6B7280"/>
                 </a:solidFill>
-                <a:latin typeface="맑은 고딕"/>
+                <a:latin typeface="Noto Sans CJK KR"/>
               </a:rPr>
               <a:t>13 / 26</a:t>
             </a:r>
@@ -6657,7 +6657,7 @@
                 <a:solidFill>
                   <a:srgbClr val="1E3A8A"/>
                 </a:solidFill>
-                <a:latin typeface="맑은 고딕"/>
+                <a:latin typeface="Noto Sans CJK KR"/>
               </a:rPr>
               <a:t>Part C — 결과</a:t>
             </a:r>
@@ -6761,7 +6761,7 @@
                 <a:solidFill>
                   <a:srgbClr val="1E3A8A"/>
                 </a:solidFill>
-                <a:latin typeface="맑은 고딕"/>
+                <a:latin typeface="Noto Sans CJK KR"/>
               </a:rPr>
               <a:t>전체 결과 — 정책별 비교 (5,000 QA)</a:t>
             </a:r>
@@ -6917,7 +6917,7 @@
                 <a:solidFill>
                   <a:srgbClr val="FFFFFF"/>
                 </a:solidFill>
-                <a:latin typeface="맑은 고딕"/>
+                <a:latin typeface="Noto Sans CJK KR"/>
               </a:rPr>
               <a:t>정책</a:t>
             </a:r>
@@ -6995,7 +6995,7 @@
                 <a:solidFill>
                   <a:srgbClr val="FFFFFF"/>
                 </a:solidFill>
-                <a:latin typeface="맑은 고딕"/>
+                <a:latin typeface="Noto Sans CJK KR"/>
               </a:rPr>
               <a:t>F1_strict</a:t>
             </a:r>
@@ -7073,7 +7073,7 @@
                 <a:solidFill>
                   <a:srgbClr val="FFFFFF"/>
                 </a:solidFill>
-                <a:latin typeface="맑은 고딕"/>
+                <a:latin typeface="Noto Sans CJK KR"/>
               </a:rPr>
               <a:t>F1_substring</a:t>
             </a:r>
@@ -7151,7 +7151,7 @@
                 <a:solidFill>
                   <a:srgbClr val="FFFFFF"/>
                 </a:solidFill>
-                <a:latin typeface="맑은 고딕"/>
+                <a:latin typeface="Noto Sans CJK KR"/>
               </a:rPr>
               <a:t>F1_char</a:t>
             </a:r>
@@ -7229,7 +7229,7 @@
                 <a:solidFill>
                   <a:srgbClr val="FFFFFF"/>
                 </a:solidFill>
-                <a:latin typeface="맑은 고딕"/>
+                <a:latin typeface="Noto Sans CJK KR"/>
               </a:rPr>
               <a:t>EM</a:t>
             </a:r>
@@ -7307,7 +7307,7 @@
                 <a:solidFill>
                   <a:srgbClr val="FFFFFF"/>
                 </a:solidFill>
-                <a:latin typeface="맑은 고딕"/>
+                <a:latin typeface="Noto Sans CJK KR"/>
               </a:rPr>
               <a:t>Faith</a:t>
             </a:r>
@@ -7385,7 +7385,7 @@
                 <a:solidFill>
                   <a:srgbClr val="FFFFFF"/>
                 </a:solidFill>
-                <a:latin typeface="맑은 고딕"/>
+                <a:latin typeface="Noto Sans CJK KR"/>
               </a:rPr>
               <a:t>Latency</a:t>
             </a:r>
@@ -7465,7 +7465,7 @@
                 <a:solidFill>
                   <a:srgbClr val="6B7280"/>
                 </a:solidFill>
-                <a:latin typeface="맑은 고딕"/>
+                <a:latin typeface="Noto Sans CJK KR"/>
               </a:rPr>
               <a:t>Vector-only</a:t>
             </a:r>
@@ -7545,7 +7545,7 @@
                 <a:solidFill>
                   <a:srgbClr val="1E293B"/>
                 </a:solidFill>
-                <a:latin typeface="맑은 고딕"/>
+                <a:latin typeface="Noto Sans CJK KR"/>
               </a:rPr>
               <a:t>0.334</a:t>
             </a:r>
@@ -7625,7 +7625,7 @@
                 <a:solidFill>
                   <a:srgbClr val="1E293B"/>
                 </a:solidFill>
-                <a:latin typeface="맑은 고딕"/>
+                <a:latin typeface="Noto Sans CJK KR"/>
               </a:rPr>
               <a:t>0.334</a:t>
             </a:r>
@@ -7705,7 +7705,7 @@
                 <a:solidFill>
                   <a:srgbClr val="1E293B"/>
                 </a:solidFill>
-                <a:latin typeface="맑은 고딕"/>
+                <a:latin typeface="Noto Sans CJK KR"/>
               </a:rPr>
               <a:t>0.317</a:t>
             </a:r>
@@ -7785,7 +7785,7 @@
                 <a:solidFill>
                   <a:srgbClr val="1E293B"/>
                 </a:solidFill>
-                <a:latin typeface="맑은 고딕"/>
+                <a:latin typeface="Noto Sans CJK KR"/>
               </a:rPr>
               <a:t>0.250</a:t>
             </a:r>
@@ -7865,7 +7865,7 @@
                 <a:solidFill>
                   <a:srgbClr val="1E293B"/>
                 </a:solidFill>
-                <a:latin typeface="맑은 고딕"/>
+                <a:latin typeface="Noto Sans CJK KR"/>
               </a:rPr>
               <a:t>0.470</a:t>
             </a:r>
@@ -7945,7 +7945,7 @@
                 <a:solidFill>
                   <a:srgbClr val="1E293B"/>
                 </a:solidFill>
-                <a:latin typeface="맑은 고딕"/>
+                <a:latin typeface="Noto Sans CJK KR"/>
               </a:rPr>
               <a:t>0.68s</a:t>
             </a:r>
@@ -8025,7 +8025,7 @@
                 <a:solidFill>
                   <a:srgbClr val="1E3A8A"/>
                 </a:solidFill>
-                <a:latin typeface="맑은 고딕"/>
+                <a:latin typeface="Noto Sans CJK KR"/>
               </a:rPr>
               <a:t>R-DWA</a:t>
             </a:r>
@@ -8105,7 +8105,7 @@
                 <a:solidFill>
                   <a:srgbClr val="1E293B"/>
                 </a:solidFill>
-                <a:latin typeface="맑은 고딕"/>
+                <a:latin typeface="Noto Sans CJK KR"/>
               </a:rPr>
               <a:t>0.529</a:t>
             </a:r>
@@ -8185,7 +8185,7 @@
                 <a:solidFill>
                   <a:srgbClr val="1E293B"/>
                 </a:solidFill>
-                <a:latin typeface="맑은 고딕"/>
+                <a:latin typeface="Noto Sans CJK KR"/>
               </a:rPr>
               <a:t>0.482</a:t>
             </a:r>
@@ -8265,7 +8265,7 @@
                 <a:solidFill>
                   <a:srgbClr val="1E293B"/>
                 </a:solidFill>
-                <a:latin typeface="맑은 고딕"/>
+                <a:latin typeface="Noto Sans CJK KR"/>
               </a:rPr>
               <a:t>0.469</a:t>
             </a:r>
@@ -8345,7 +8345,7 @@
                 <a:solidFill>
                   <a:srgbClr val="1E293B"/>
                 </a:solidFill>
-                <a:latin typeface="맑은 고딕"/>
+                <a:latin typeface="Noto Sans CJK KR"/>
               </a:rPr>
               <a:t>0.387</a:t>
             </a:r>
@@ -8425,7 +8425,7 @@
                 <a:solidFill>
                   <a:srgbClr val="1E293B"/>
                 </a:solidFill>
-                <a:latin typeface="맑은 고딕"/>
+                <a:latin typeface="Noto Sans CJK KR"/>
               </a:rPr>
               <a:t>0.544</a:t>
             </a:r>
@@ -8505,7 +8505,7 @@
                 <a:solidFill>
                   <a:srgbClr val="1E293B"/>
                 </a:solidFill>
-                <a:latin typeface="맑은 고딕"/>
+                <a:latin typeface="Noto Sans CJK KR"/>
               </a:rPr>
               <a:t>0.71s</a:t>
             </a:r>
@@ -8585,7 +8585,7 @@
                 <a:solidFill>
                   <a:srgbClr val="E8756E"/>
                 </a:solidFill>
-                <a:latin typeface="맑은 고딕"/>
+                <a:latin typeface="Noto Sans CJK KR"/>
               </a:rPr>
               <a:t>L-DWA (3-seed)</a:t>
             </a:r>
@@ -8665,7 +8665,7 @@
                 <a:solidFill>
                   <a:srgbClr val="1E293B"/>
                 </a:solidFill>
-                <a:latin typeface="맑은 고딕"/>
+                <a:latin typeface="Noto Sans CJK KR"/>
               </a:rPr>
               <a:t>0.562</a:t>
             </a:r>
@@ -8745,7 +8745,7 @@
                 <a:solidFill>
                   <a:srgbClr val="1E293B"/>
                 </a:solidFill>
-                <a:latin typeface="맑은 고딕"/>
+                <a:latin typeface="Noto Sans CJK KR"/>
               </a:rPr>
               <a:t>0.507</a:t>
             </a:r>
@@ -8825,7 +8825,7 @@
                 <a:solidFill>
                   <a:srgbClr val="1E293B"/>
                 </a:solidFill>
-                <a:latin typeface="맑은 고딕"/>
+                <a:latin typeface="Noto Sans CJK KR"/>
               </a:rPr>
               <a:t>0.494</a:t>
             </a:r>
@@ -8905,7 +8905,7 @@
                 <a:solidFill>
                   <a:srgbClr val="1E293B"/>
                 </a:solidFill>
-                <a:latin typeface="맑은 고딕"/>
+                <a:latin typeface="Noto Sans CJK KR"/>
               </a:rPr>
               <a:t>0.388</a:t>
             </a:r>
@@ -8985,7 +8985,7 @@
                 <a:solidFill>
                   <a:srgbClr val="1E293B"/>
                 </a:solidFill>
-                <a:latin typeface="맑은 고딕"/>
+                <a:latin typeface="Noto Sans CJK KR"/>
               </a:rPr>
               <a:t>0.580</a:t>
             </a:r>
@@ -9065,7 +9065,7 @@
                 <a:solidFill>
                   <a:srgbClr val="1E293B"/>
                 </a:solidFill>
-                <a:latin typeface="맑은 고딕"/>
+                <a:latin typeface="Noto Sans CJK KR"/>
               </a:rPr>
               <a:t>0.76s</a:t>
             </a:r>
@@ -9145,7 +9145,7 @@
                 <a:solidFill>
                   <a:srgbClr val="8FB573"/>
                 </a:solidFill>
-                <a:latin typeface="맑은 고딕"/>
+                <a:latin typeface="Noto Sans CJK KR"/>
               </a:rPr>
               <a:t>Oracle</a:t>
             </a:r>
@@ -9225,7 +9225,7 @@
                 <a:solidFill>
                   <a:srgbClr val="1E293B"/>
                 </a:solidFill>
-                <a:latin typeface="맑은 고딕"/>
+                <a:latin typeface="Noto Sans CJK KR"/>
               </a:rPr>
               <a:t>0.554</a:t>
             </a:r>
@@ -9305,7 +9305,7 @@
                 <a:solidFill>
                   <a:srgbClr val="1E293B"/>
                 </a:solidFill>
-                <a:latin typeface="맑은 고딕"/>
+                <a:latin typeface="Noto Sans CJK KR"/>
               </a:rPr>
               <a:t>0.504</a:t>
             </a:r>
@@ -9385,7 +9385,7 @@
                 <a:solidFill>
                   <a:srgbClr val="1E293B"/>
                 </a:solidFill>
-                <a:latin typeface="맑은 고딕"/>
+                <a:latin typeface="Noto Sans CJK KR"/>
               </a:rPr>
               <a:t>0.487</a:t>
             </a:r>
@@ -9465,7 +9465,7 @@
                 <a:solidFill>
                   <a:srgbClr val="1E293B"/>
                 </a:solidFill>
-                <a:latin typeface="맑은 고딕"/>
+                <a:latin typeface="Noto Sans CJK KR"/>
               </a:rPr>
               <a:t>0.388</a:t>
             </a:r>
@@ -9545,7 +9545,7 @@
                 <a:solidFill>
                   <a:srgbClr val="1E293B"/>
                 </a:solidFill>
-                <a:latin typeface="맑은 고딕"/>
+                <a:latin typeface="Noto Sans CJK KR"/>
               </a:rPr>
               <a:t>0.570</a:t>
             </a:r>
@@ -9625,7 +9625,7 @@
                 <a:solidFill>
                   <a:srgbClr val="1E293B"/>
                 </a:solidFill>
-                <a:latin typeface="맑은 고딕"/>
+                <a:latin typeface="Noto Sans CJK KR"/>
               </a:rPr>
               <a:t>0.75s</a:t>
             </a:r>
@@ -9660,7 +9660,7 @@
                 <a:solidFill>
                   <a:srgbClr val="1E3A8A"/>
                 </a:solidFill>
-                <a:latin typeface="맑은 고딕"/>
+                <a:latin typeface="Noto Sans CJK KR"/>
               </a:rPr>
               <a:t>핵심: L-DWA 3-seed 평균이 R-DWA 대비 F1_strict +6.2%,</a:t>
             </a:r>
@@ -9672,7 +9672,7 @@
                 <a:solidFill>
                   <a:srgbClr val="1E3A8A"/>
                 </a:solidFill>
-                <a:latin typeface="맑은 고딕"/>
+                <a:latin typeface="Noto Sans CJK KR"/>
               </a:rPr>
               <a:t>       Faithfulness +6.6%, 그리고 Oracle 0.554 를 네 F1 축 모두에서 초과.</a:t>
             </a:r>
@@ -9684,7 +9684,7 @@
                 <a:solidFill>
                   <a:srgbClr val="1E3A8A"/>
                 </a:solidFill>
-                <a:latin typeface="맑은 고딕"/>
+                <a:latin typeface="Noto Sans CJK KR"/>
               </a:rPr>
               <a:t>       3-seed 표준편차는 ±0.007 수준으로 극히 안정적.</a:t>
             </a:r>
@@ -9762,7 +9762,7 @@
                 <a:solidFill>
                   <a:srgbClr val="6B7280"/>
                 </a:solidFill>
-                <a:latin typeface="맑은 고딕"/>
+                <a:latin typeface="Noto Sans CJK KR"/>
               </a:rPr>
               <a:t>신동욱 (Shin Dong-wook) · 호서대학교 대학원 융합공학과 · 박사학위 방어 발표</a:t>
             </a:r>
@@ -9797,7 +9797,7 @@
                 <a:solidFill>
                   <a:srgbClr val="6B7280"/>
                 </a:solidFill>
-                <a:latin typeface="맑은 고딕"/>
+                <a:latin typeface="Noto Sans CJK KR"/>
               </a:rPr>
               <a:t>14 / 26</a:t>
             </a:r>
@@ -9832,7 +9832,7 @@
                 <a:solidFill>
                   <a:srgbClr val="1E3A8A"/>
                 </a:solidFill>
-                <a:latin typeface="맑은 고딕"/>
+                <a:latin typeface="Noto Sans CJK KR"/>
               </a:rPr>
               <a:t>Part C — 결과</a:t>
             </a:r>
@@ -9936,7 +9936,7 @@
                 <a:solidFill>
                   <a:srgbClr val="1E3A8A"/>
                 </a:solidFill>
-                <a:latin typeface="맑은 고딕"/>
+                <a:latin typeface="Noto Sans CJK KR"/>
               </a:rPr>
               <a:t>유형별 F1 — 어디서 개선 폭이 큰가</a:t>
             </a:r>
@@ -10049,7 +10049,7 @@
                 <a:solidFill>
                   <a:srgbClr val="1E3A8A"/>
                 </a:solidFill>
-                <a:latin typeface="맑은 고딕"/>
+                <a:latin typeface="Noto Sans CJK KR"/>
               </a:rPr>
               <a:t>유형별 F1_strict</a:t>
             </a:r>
@@ -10318,7 +10318,7 @@
                 <a:solidFill>
                   <a:srgbClr val="6B7280"/>
                 </a:solidFill>
-                <a:latin typeface="맑은 고딕"/>
+                <a:latin typeface="Noto Sans CJK KR"/>
               </a:rPr>
               <a:t>신동욱 (Shin Dong-wook) · 호서대학교 대학원 융합공학과 · 박사학위 방어 발표</a:t>
             </a:r>
@@ -10353,7 +10353,7 @@
                 <a:solidFill>
                   <a:srgbClr val="6B7280"/>
                 </a:solidFill>
-                <a:latin typeface="맑은 고딕"/>
+                <a:latin typeface="Noto Sans CJK KR"/>
               </a:rPr>
               <a:t>15 / 26</a:t>
             </a:r>
@@ -10388,7 +10388,7 @@
                 <a:solidFill>
                   <a:srgbClr val="1E3A8A"/>
                 </a:solidFill>
-                <a:latin typeface="맑은 고딕"/>
+                <a:latin typeface="Noto Sans CJK KR"/>
               </a:rPr>
               <a:t>Part C — 결과</a:t>
             </a:r>
@@ -10492,7 +10492,7 @@
                 <a:solidFill>
                   <a:srgbClr val="1E3A8A"/>
                 </a:solidFill>
-                <a:latin typeface="맑은 고딕"/>
+                <a:latin typeface="Noto Sans CJK KR"/>
               </a:rPr>
               <a:t>핵심 결과 ① — 이산 Oracle 상한 초과</a:t>
             </a:r>
@@ -10605,7 +10605,7 @@
                 <a:solidFill>
                   <a:srgbClr val="E8756E"/>
                 </a:solidFill>
-                <a:latin typeface="맑은 고딕"/>
+                <a:latin typeface="Noto Sans CJK KR"/>
               </a:rPr>
               <a:t>66-점 이산 격자 argmax Oracle (F1_strict 0.554) 을</a:t>
             </a:r>
@@ -10617,7 +10617,7 @@
                 <a:solidFill>
                   <a:srgbClr val="E8756E"/>
                 </a:solidFill>
-                <a:latin typeface="맑은 고딕"/>
+                <a:latin typeface="Noto Sans CJK KR"/>
               </a:rPr>
               <a:t>학습된 연속 Dirichlet 평균이 네 개 F1 축 모두에서 미세하게 초과</a:t>
             </a:r>
@@ -10695,7 +10695,7 @@
                 <a:solidFill>
                   <a:srgbClr val="FFFFFF"/>
                 </a:solidFill>
-                <a:latin typeface="맑은 고딕"/>
+                <a:latin typeface="Noto Sans CJK KR"/>
               </a:rPr>
               <a:t>지표</a:t>
             </a:r>
@@ -10773,7 +10773,7 @@
                 <a:solidFill>
                   <a:srgbClr val="FFFFFF"/>
                 </a:solidFill>
-                <a:latin typeface="맑은 고딕"/>
+                <a:latin typeface="Noto Sans CJK KR"/>
               </a:rPr>
               <a:t>R-DWA</a:t>
             </a:r>
@@ -10851,7 +10851,7 @@
                 <a:solidFill>
                   <a:srgbClr val="FFFFFF"/>
                 </a:solidFill>
-                <a:latin typeface="맑은 고딕"/>
+                <a:latin typeface="Noto Sans CJK KR"/>
               </a:rPr>
               <a:t>Oracle</a:t>
             </a:r>
@@ -10929,7 +10929,7 @@
                 <a:solidFill>
                   <a:srgbClr val="FFFFFF"/>
                 </a:solidFill>
-                <a:latin typeface="맑은 고딕"/>
+                <a:latin typeface="Noto Sans CJK KR"/>
               </a:rPr>
               <a:t>L-DWA</a:t>
             </a:r>
@@ -11009,7 +11009,7 @@
                 <a:solidFill>
                   <a:srgbClr val="1E293B"/>
                 </a:solidFill>
-                <a:latin typeface="맑은 고딕"/>
+                <a:latin typeface="Noto Sans CJK KR"/>
               </a:rPr>
               <a:t>F1_strict</a:t>
             </a:r>
@@ -11089,7 +11089,7 @@
                 <a:solidFill>
                   <a:srgbClr val="1E293B"/>
                 </a:solidFill>
-                <a:latin typeface="맑은 고딕"/>
+                <a:latin typeface="Noto Sans CJK KR"/>
               </a:rPr>
               <a:t>0.529</a:t>
             </a:r>
@@ -11169,7 +11169,7 @@
                 <a:solidFill>
                   <a:srgbClr val="1E293B"/>
                 </a:solidFill>
-                <a:latin typeface="맑은 고딕"/>
+                <a:latin typeface="Noto Sans CJK KR"/>
               </a:rPr>
               <a:t>0.554</a:t>
             </a:r>
@@ -11249,7 +11249,7 @@
                 <a:solidFill>
                   <a:srgbClr val="E8756E"/>
                 </a:solidFill>
-                <a:latin typeface="맑은 고딕"/>
+                <a:latin typeface="Noto Sans CJK KR"/>
               </a:rPr>
               <a:t>0.562</a:t>
             </a:r>
@@ -11329,7 +11329,7 @@
                 <a:solidFill>
                   <a:srgbClr val="1E293B"/>
                 </a:solidFill>
-                <a:latin typeface="맑은 고딕"/>
+                <a:latin typeface="Noto Sans CJK KR"/>
               </a:rPr>
               <a:t>F1_substring</a:t>
             </a:r>
@@ -11409,7 +11409,7 @@
                 <a:solidFill>
                   <a:srgbClr val="1E293B"/>
                 </a:solidFill>
-                <a:latin typeface="맑은 고딕"/>
+                <a:latin typeface="Noto Sans CJK KR"/>
               </a:rPr>
               <a:t>0.482</a:t>
             </a:r>
@@ -11489,7 +11489,7 @@
                 <a:solidFill>
                   <a:srgbClr val="1E293B"/>
                 </a:solidFill>
-                <a:latin typeface="맑은 고딕"/>
+                <a:latin typeface="Noto Sans CJK KR"/>
               </a:rPr>
               <a:t>0.504</a:t>
             </a:r>
@@ -11569,7 +11569,7 @@
                 <a:solidFill>
                   <a:srgbClr val="E8756E"/>
                 </a:solidFill>
-                <a:latin typeface="맑은 고딕"/>
+                <a:latin typeface="Noto Sans CJK KR"/>
               </a:rPr>
               <a:t>0.507</a:t>
             </a:r>
@@ -11649,7 +11649,7 @@
                 <a:solidFill>
                   <a:srgbClr val="1E293B"/>
                 </a:solidFill>
-                <a:latin typeface="맑은 고딕"/>
+                <a:latin typeface="Noto Sans CJK KR"/>
               </a:rPr>
               <a:t>F1_char</a:t>
             </a:r>
@@ -11729,7 +11729,7 @@
                 <a:solidFill>
                   <a:srgbClr val="1E293B"/>
                 </a:solidFill>
-                <a:latin typeface="맑은 고딕"/>
+                <a:latin typeface="Noto Sans CJK KR"/>
               </a:rPr>
               <a:t>0.469</a:t>
             </a:r>
@@ -11809,7 +11809,7 @@
                 <a:solidFill>
                   <a:srgbClr val="1E293B"/>
                 </a:solidFill>
-                <a:latin typeface="맑은 고딕"/>
+                <a:latin typeface="Noto Sans CJK KR"/>
               </a:rPr>
               <a:t>0.487</a:t>
             </a:r>
@@ -11889,7 +11889,7 @@
                 <a:solidFill>
                   <a:srgbClr val="E8756E"/>
                 </a:solidFill>
-                <a:latin typeface="맑은 고딕"/>
+                <a:latin typeface="Noto Sans CJK KR"/>
               </a:rPr>
               <a:t>0.494</a:t>
             </a:r>
@@ -11969,7 +11969,7 @@
                 <a:solidFill>
                   <a:srgbClr val="1E293B"/>
                 </a:solidFill>
-                <a:latin typeface="맑은 고딕"/>
+                <a:latin typeface="Noto Sans CJK KR"/>
               </a:rPr>
               <a:t>Faithfulness</a:t>
             </a:r>
@@ -12049,7 +12049,7 @@
                 <a:solidFill>
                   <a:srgbClr val="1E293B"/>
                 </a:solidFill>
-                <a:latin typeface="맑은 고딕"/>
+                <a:latin typeface="Noto Sans CJK KR"/>
               </a:rPr>
               <a:t>0.544</a:t>
             </a:r>
@@ -12129,7 +12129,7 @@
                 <a:solidFill>
                   <a:srgbClr val="1E293B"/>
                 </a:solidFill>
-                <a:latin typeface="맑은 고딕"/>
+                <a:latin typeface="Noto Sans CJK KR"/>
               </a:rPr>
               <a:t>0.570</a:t>
             </a:r>
@@ -12209,7 +12209,7 @@
                 <a:solidFill>
                   <a:srgbClr val="E8756E"/>
                 </a:solidFill>
-                <a:latin typeface="맑은 고딕"/>
+                <a:latin typeface="Noto Sans CJK KR"/>
               </a:rPr>
               <a:t>0.580</a:t>
             </a:r>
@@ -12244,7 +12244,7 @@
                 <a:solidFill>
                   <a:srgbClr val="1E3A8A"/>
                 </a:solidFill>
-                <a:latin typeface="맑은 고딕"/>
+                <a:latin typeface="Noto Sans CJK KR"/>
               </a:rPr>
               <a:t>해석 — Oracle 은 66개 이산 점 중 argmax. L-DWA 의 Dirichlet 평균은</a:t>
             </a:r>
@@ -12256,7 +12256,7 @@
                 <a:solidFill>
                   <a:srgbClr val="1E3A8A"/>
                 </a:solidFill>
-                <a:latin typeface="맑은 고딕"/>
+                <a:latin typeface="Noto Sans CJK KR"/>
               </a:rPr>
               <a:t>연속 공간 → 격자 바깥 지점을 활용 가능. 양적 개선이 아닌 질적 의미.</a:t>
             </a:r>
@@ -12334,7 +12334,7 @@
                 <a:solidFill>
                   <a:srgbClr val="6B7280"/>
                 </a:solidFill>
-                <a:latin typeface="맑은 고딕"/>
+                <a:latin typeface="Noto Sans CJK KR"/>
               </a:rPr>
               <a:t>신동욱 (Shin Dong-wook) · 호서대학교 대학원 융합공학과 · 박사학위 방어 발표</a:t>
             </a:r>
@@ -12369,7 +12369,7 @@
                 <a:solidFill>
                   <a:srgbClr val="6B7280"/>
                 </a:solidFill>
-                <a:latin typeface="맑은 고딕"/>
+                <a:latin typeface="Noto Sans CJK KR"/>
               </a:rPr>
               <a:t>16 / 26</a:t>
             </a:r>
@@ -12404,7 +12404,7 @@
                 <a:solidFill>
                   <a:srgbClr val="1E3A8A"/>
                 </a:solidFill>
-                <a:latin typeface="맑은 고딕"/>
+                <a:latin typeface="Noto Sans CJK KR"/>
               </a:rPr>
               <a:t>Part C — 결과</a:t>
             </a:r>
@@ -12508,7 +12508,7 @@
                 <a:solidFill>
                   <a:srgbClr val="1E3A8A"/>
                 </a:solidFill>
-                <a:latin typeface="맑은 고딕"/>
+                <a:latin typeface="Noto Sans CJK KR"/>
               </a:rPr>
               <a:t>핵심 결과 ② — Conditional +36.7%</a:t>
             </a:r>
@@ -12621,7 +12621,7 @@
                 <a:solidFill>
                   <a:srgbClr val="E8756E"/>
                 </a:solidFill>
-                <a:latin typeface="맑은 고딕"/>
+                <a:latin typeface="Noto Sans CJK KR"/>
               </a:rPr>
               <a:t>조건부 질의 (n = 1,250) 에서 가장 큰 상대 개선.</a:t>
             </a:r>
@@ -12633,7 +12633,7 @@
                 <a:solidFill>
                   <a:srgbClr val="E8756E"/>
                 </a:solidFill>
-                <a:latin typeface="맑은 고딕"/>
+                <a:latin typeface="Noto Sans CJK KR"/>
               </a:rPr>
               <a:t>L-DWA 가 Oracle 마저 근소하게 초과.</a:t>
             </a:r>
@@ -12713,7 +12713,7 @@
                 <a:solidFill>
                   <a:srgbClr val="6B7280"/>
                 </a:solidFill>
-                <a:latin typeface="맑은 고딕"/>
+                <a:latin typeface="Noto Sans CJK KR"/>
               </a:rPr>
               <a:t>R-DWA</a:t>
             </a:r>
@@ -12725,7 +12725,7 @@
                 <a:solidFill>
                   <a:srgbClr val="6B7280"/>
                 </a:solidFill>
-                <a:latin typeface="맑은 고딕"/>
+                <a:latin typeface="Noto Sans CJK KR"/>
               </a:rPr>
               <a:t>(기존 규칙 표)</a:t>
             </a:r>
@@ -12760,7 +12760,7 @@
                 <a:solidFill>
                   <a:srgbClr val="6B7280"/>
                 </a:solidFill>
-                <a:latin typeface="맑은 고딕"/>
+                <a:latin typeface="Noto Sans CJK KR"/>
               </a:rPr>
               <a:t>0.223</a:t>
             </a:r>
@@ -12795,7 +12795,7 @@
                 <a:solidFill>
                   <a:srgbClr val="6B7280"/>
                 </a:solidFill>
-                <a:latin typeface="맑은 고딕"/>
+                <a:latin typeface="Noto Sans CJK KR"/>
               </a:rPr>
               <a:t>고정 (0.2, 0.2, 0.6)</a:t>
             </a:r>
@@ -12875,7 +12875,7 @@
                 <a:solidFill>
                   <a:srgbClr val="8FB573"/>
                 </a:solidFill>
-                <a:latin typeface="맑은 고딕"/>
+                <a:latin typeface="Noto Sans CJK KR"/>
               </a:rPr>
               <a:t>Oracle</a:t>
             </a:r>
@@ -12887,7 +12887,7 @@
                 <a:solidFill>
                   <a:srgbClr val="8FB573"/>
                 </a:solidFill>
-                <a:latin typeface="맑은 고딕"/>
+                <a:latin typeface="Noto Sans CJK KR"/>
               </a:rPr>
               <a:t>(이산 상한)</a:t>
             </a:r>
@@ -12922,7 +12922,7 @@
                 <a:solidFill>
                   <a:srgbClr val="8FB573"/>
                 </a:solidFill>
-                <a:latin typeface="맑은 고딕"/>
+                <a:latin typeface="Noto Sans CJK KR"/>
               </a:rPr>
               <a:t>0.290</a:t>
             </a:r>
@@ -12957,7 +12957,7 @@
                 <a:solidFill>
                   <a:srgbClr val="6B7280"/>
                 </a:solidFill>
-                <a:latin typeface="맑은 고딕"/>
+                <a:latin typeface="Noto Sans CJK KR"/>
               </a:rPr>
               <a:t>66-점 argmax</a:t>
             </a:r>
@@ -13037,7 +13037,7 @@
                 <a:solidFill>
                   <a:srgbClr val="E8756E"/>
                 </a:solidFill>
-                <a:latin typeface="맑은 고딕"/>
+                <a:latin typeface="Noto Sans CJK KR"/>
               </a:rPr>
               <a:t>L-DWA</a:t>
             </a:r>
@@ -13049,7 +13049,7 @@
                 <a:solidFill>
                   <a:srgbClr val="E8756E"/>
                 </a:solidFill>
-                <a:latin typeface="맑은 고딕"/>
+                <a:latin typeface="Noto Sans CJK KR"/>
               </a:rPr>
               <a:t>(본 연구)</a:t>
             </a:r>
@@ -13084,7 +13084,7 @@
                 <a:solidFill>
                   <a:srgbClr val="E8756E"/>
                 </a:solidFill>
-                <a:latin typeface="맑은 고딕"/>
+                <a:latin typeface="Noto Sans CJK KR"/>
               </a:rPr>
               <a:t>0.304</a:t>
             </a:r>
@@ -13119,7 +13119,7 @@
                 <a:solidFill>
                   <a:srgbClr val="6B7280"/>
                 </a:solidFill>
-                <a:latin typeface="맑은 고딕"/>
+                <a:latin typeface="Noto Sans CJK KR"/>
               </a:rPr>
               <a:t>질의별 동적 가중치</a:t>
             </a:r>
@@ -13154,7 +13154,7 @@
                 <a:solidFill>
                   <a:srgbClr val="1E3A8A"/>
                 </a:solidFill>
-                <a:latin typeface="맑은 고딕"/>
+                <a:latin typeface="Noto Sans CJK KR"/>
               </a:rPr>
               <a:t>해석 — 같은 conditional 이라도 수치 제약 · 열거형 · 배타 조건이 각기 다른데,</a:t>
             </a:r>
@@ -13166,7 +13166,7 @@
                 <a:solidFill>
                   <a:srgbClr val="1E3A8A"/>
                 </a:solidFill>
-                <a:latin typeface="맑은 고딕"/>
+                <a:latin typeface="Noto Sans CJK KR"/>
               </a:rPr>
               <a:t>R-DWA 는 이들을 하나로 묶어 처리. 학습이 내부 차이를 포착.</a:t>
             </a:r>
@@ -13244,7 +13244,7 @@
                 <a:solidFill>
                   <a:srgbClr val="6B7280"/>
                 </a:solidFill>
-                <a:latin typeface="맑은 고딕"/>
+                <a:latin typeface="Noto Sans CJK KR"/>
               </a:rPr>
               <a:t>신동욱 (Shin Dong-wook) · 호서대학교 대학원 융합공학과 · 박사학위 방어 발표</a:t>
             </a:r>
@@ -13279,7 +13279,7 @@
                 <a:solidFill>
                   <a:srgbClr val="6B7280"/>
                 </a:solidFill>
-                <a:latin typeface="맑은 고딕"/>
+                <a:latin typeface="Noto Sans CJK KR"/>
               </a:rPr>
               <a:t>17 / 26</a:t>
             </a:r>
@@ -13314,7 +13314,7 @@
                 <a:solidFill>
                   <a:srgbClr val="1E3A8A"/>
                 </a:solidFill>
-                <a:latin typeface="맑은 고딕"/>
+                <a:latin typeface="Noto Sans CJK KR"/>
               </a:rPr>
               <a:t>Part C — 결과</a:t>
             </a:r>
@@ -13418,7 +13418,7 @@
                 <a:solidFill>
                   <a:srgbClr val="1E3A8A"/>
                 </a:solidFill>
-                <a:latin typeface="맑은 고딕"/>
+                <a:latin typeface="Noto Sans CJK KR"/>
               </a:rPr>
               <a:t>Δ³ 위 정책별 평균 가중치 분포</a:t>
             </a:r>
@@ -13531,7 +13531,7 @@
                 <a:solidFill>
                   <a:srgbClr val="1E3A8A"/>
                 </a:solidFill>
-                <a:latin typeface="맑은 고딕"/>
+                <a:latin typeface="Noto Sans CJK KR"/>
               </a:rPr>
               <a:t>읽는 법</a:t>
             </a:r>
@@ -13721,7 +13721,7 @@
                 <a:solidFill>
                   <a:srgbClr val="1E3A8A"/>
                 </a:solidFill>
-                <a:latin typeface="맑은 고딕"/>
+                <a:latin typeface="Noto Sans CJK KR"/>
               </a:rPr>
               <a:t>정답 분포의 진짜 지형은 Ontology 지배적. R-DWA 는 이를 반영하지 못함.</a:t>
             </a:r>
@@ -13799,7 +13799,7 @@
                 <a:solidFill>
                   <a:srgbClr val="6B7280"/>
                 </a:solidFill>
-                <a:latin typeface="맑은 고딕"/>
+                <a:latin typeface="Noto Sans CJK KR"/>
               </a:rPr>
               <a:t>신동욱 (Shin Dong-wook) · 호서대학교 대학원 융합공학과 · 박사학위 방어 발표</a:t>
             </a:r>
@@ -13834,7 +13834,7 @@
                 <a:solidFill>
                   <a:srgbClr val="6B7280"/>
                 </a:solidFill>
-                <a:latin typeface="맑은 고딕"/>
+                <a:latin typeface="Noto Sans CJK KR"/>
               </a:rPr>
               <a:t>18 / 26</a:t>
             </a:r>
@@ -13869,7 +13869,7 @@
                 <a:solidFill>
                   <a:srgbClr val="1E3A8A"/>
                 </a:solidFill>
-                <a:latin typeface="맑은 고딕"/>
+                <a:latin typeface="Noto Sans CJK KR"/>
               </a:rPr>
               <a:t>Part C — 결과</a:t>
             </a:r>
@@ -13973,7 +13973,7 @@
                 <a:solidFill>
                   <a:srgbClr val="1E3A8A"/>
                 </a:solidFill>
-                <a:latin typeface="맑은 고딕"/>
+                <a:latin typeface="Noto Sans CJK KR"/>
               </a:rPr>
               <a:t>PPO 3-seed 학습 곡선</a:t>
             </a:r>
@@ -14086,7 +14086,7 @@
                 <a:solidFill>
                   <a:srgbClr val="1E3A8A"/>
                 </a:solidFill>
-                <a:latin typeface="맑은 고딕"/>
+                <a:latin typeface="Noto Sans CJK KR"/>
               </a:rPr>
               <a:t>세 시드 모두 mean_reward ≈ 0.215 ± 0.002 로 수렴.</a:t>
             </a:r>
@@ -14098,7 +14098,7 @@
                 <a:solidFill>
                   <a:srgbClr val="1E3A8A"/>
                 </a:solidFill>
-                <a:latin typeface="맑은 고딕"/>
+                <a:latin typeface="Noto Sans CJK KR"/>
               </a:rPr>
               <a:t>1% 미만의 표준편차 → 학습 자체의 재현 가능성 확보.</a:t>
             </a:r>
@@ -14176,7 +14176,7 @@
                 <a:solidFill>
                   <a:srgbClr val="6B7280"/>
                 </a:solidFill>
-                <a:latin typeface="맑은 고딕"/>
+                <a:latin typeface="Noto Sans CJK KR"/>
               </a:rPr>
               <a:t>신동욱 (Shin Dong-wook) · 호서대학교 대학원 융합공학과 · 박사학위 방어 발표</a:t>
             </a:r>
@@ -14211,7 +14211,7 @@
                 <a:solidFill>
                   <a:srgbClr val="6B7280"/>
                 </a:solidFill>
-                <a:latin typeface="맑은 고딕"/>
+                <a:latin typeface="Noto Sans CJK KR"/>
               </a:rPr>
               <a:t>19 / 26</a:t>
             </a:r>
@@ -14246,7 +14246,7 @@
                 <a:solidFill>
                   <a:srgbClr val="1E3A8A"/>
                 </a:solidFill>
-                <a:latin typeface="맑은 고딕"/>
+                <a:latin typeface="Noto Sans CJK KR"/>
               </a:rPr>
               <a:t>Part C — 결과</a:t>
             </a:r>
@@ -14350,7 +14350,7 @@
                 <a:solidFill>
                   <a:srgbClr val="1E3A8A"/>
                 </a:solidFill>
-                <a:latin typeface="맑은 고딕"/>
+                <a:latin typeface="Noto Sans CJK KR"/>
               </a:rPr>
               <a:t>발표 목차</a:t>
             </a:r>
@@ -14506,7 +14506,7 @@
                 <a:solidFill>
                   <a:srgbClr val="1E3A8A"/>
                 </a:solidFill>
-                <a:latin typeface="맑은 고딕"/>
+                <a:latin typeface="Noto Sans CJK KR"/>
               </a:rPr>
               <a:t>Part A</a:t>
             </a:r>
@@ -14541,7 +14541,7 @@
                 <a:solidFill>
                   <a:srgbClr val="1E293B"/>
                 </a:solidFill>
-                <a:latin typeface="맑은 고딕"/>
+                <a:latin typeface="Noto Sans CJK KR"/>
               </a:rPr>
               <a:t>Opening</a:t>
             </a:r>
@@ -14576,7 +14576,7 @@
                 <a:solidFill>
                   <a:srgbClr val="6B7280"/>
                 </a:solidFill>
-                <a:latin typeface="맑은 고딕"/>
+                <a:latin typeface="Noto Sans CJK KR"/>
               </a:rPr>
               <a:t>연구 한눈에 보기 · 핵심 결과 요약</a:t>
             </a:r>
@@ -14654,7 +14654,7 @@
                 <a:solidFill>
                   <a:srgbClr val="4F86C6"/>
                 </a:solidFill>
-                <a:latin typeface="맑은 고딕"/>
+                <a:latin typeface="Noto Sans CJK KR"/>
               </a:rPr>
               <a:t>Part B</a:t>
             </a:r>
@@ -14689,7 +14689,7 @@
                 <a:solidFill>
                   <a:srgbClr val="1E293B"/>
                 </a:solidFill>
-                <a:latin typeface="맑은 고딕"/>
+                <a:latin typeface="Noto Sans CJK KR"/>
               </a:rPr>
               <a:t>문제와 방법</a:t>
             </a:r>
@@ -14724,7 +14724,7 @@
                 <a:solidFill>
                   <a:srgbClr val="6B7280"/>
                 </a:solidFill>
-                <a:latin typeface="맑은 고딕"/>
+                <a:latin typeface="Noto Sans CJK KR"/>
               </a:rPr>
               <a:t>Triple-Hybrid RAG · α·β·γ 가중치 문제 · R-DWA 와 L-DWA</a:t>
             </a:r>
@@ -14802,7 +14802,7 @@
                 <a:solidFill>
                   <a:srgbClr val="E8756E"/>
                 </a:solidFill>
-                <a:latin typeface="맑은 고딕"/>
+                <a:latin typeface="Noto Sans CJK KR"/>
               </a:rPr>
               <a:t>Part C</a:t>
             </a:r>
@@ -14837,7 +14837,7 @@
                 <a:solidFill>
                   <a:srgbClr val="1E293B"/>
                 </a:solidFill>
-                <a:latin typeface="맑은 고딕"/>
+                <a:latin typeface="Noto Sans CJK KR"/>
               </a:rPr>
               <a:t>결과</a:t>
             </a:r>
@@ -14872,7 +14872,7 @@
                 <a:solidFill>
                   <a:srgbClr val="6B7280"/>
                 </a:solidFill>
-                <a:latin typeface="맑은 고딕"/>
+                <a:latin typeface="Noto Sans CJK KR"/>
               </a:rPr>
               <a:t>5,000 QA 정량 비교 · Oracle 초과 · Conditional 개선</a:t>
             </a:r>
@@ -14950,7 +14950,7 @@
                 <a:solidFill>
                   <a:srgbClr val="8FB573"/>
                 </a:solidFill>
-                <a:latin typeface="맑은 고딕"/>
+                <a:latin typeface="Noto Sans CJK KR"/>
               </a:rPr>
               <a:t>Part D</a:t>
             </a:r>
@@ -14985,7 +14985,7 @@
                 <a:solidFill>
                   <a:srgbClr val="1E293B"/>
                 </a:solidFill>
-                <a:latin typeface="맑은 고딕"/>
+                <a:latin typeface="Noto Sans CJK KR"/>
               </a:rPr>
               <a:t>결론</a:t>
             </a:r>
@@ -15020,7 +15020,7 @@
                 <a:solidFill>
                   <a:srgbClr val="6B7280"/>
                 </a:solidFill>
-                <a:latin typeface="맑은 고딕"/>
+                <a:latin typeface="Noto Sans CJK KR"/>
               </a:rPr>
               <a:t>기여 · 한계 · 향후 연구 방향</a:t>
             </a:r>
@@ -15055,7 +15055,7 @@
                 <a:solidFill>
                   <a:srgbClr val="6B7280"/>
                 </a:solidFill>
-                <a:latin typeface="맑은 고딕"/>
+                <a:latin typeface="Noto Sans CJK KR"/>
               </a:rPr>
               <a:t>발표 시간: 약 18분 · 슬라이드 26장 + Appendix</a:t>
             </a:r>
@@ -15133,7 +15133,7 @@
                 <a:solidFill>
                   <a:srgbClr val="6B7280"/>
                 </a:solidFill>
-                <a:latin typeface="맑은 고딕"/>
+                <a:latin typeface="Noto Sans CJK KR"/>
               </a:rPr>
               <a:t>신동욱 (Shin Dong-wook) · 호서대학교 대학원 융합공학과 · 박사학위 방어 발표</a:t>
             </a:r>
@@ -15168,7 +15168,7 @@
                 <a:solidFill>
                   <a:srgbClr val="6B7280"/>
                 </a:solidFill>
-                <a:latin typeface="맑은 고딕"/>
+                <a:latin typeface="Noto Sans CJK KR"/>
               </a:rPr>
               <a:t>2 / 26</a:t>
             </a:r>
@@ -15203,7 +15203,7 @@
                 <a:solidFill>
                   <a:srgbClr val="1E3A8A"/>
                 </a:solidFill>
-                <a:latin typeface="맑은 고딕"/>
+                <a:latin typeface="Noto Sans CJK KR"/>
               </a:rPr>
               <a:t>Part A — Opening</a:t>
             </a:r>
@@ -15307,7 +15307,7 @@
                 <a:solidFill>
                   <a:srgbClr val="1E3A8A"/>
                 </a:solidFill>
-                <a:latin typeface="맑은 고딕"/>
+                <a:latin typeface="Noto Sans CJK KR"/>
               </a:rPr>
               <a:t>교차 도메인 — naive transfer 의 한계와 원인 분해</a:t>
             </a:r>
@@ -15420,7 +15420,7 @@
                 <a:solidFill>
                   <a:srgbClr val="E8756E"/>
                 </a:solidFill>
-                <a:latin typeface="맑은 고딕"/>
+                <a:latin typeface="Noto Sans CJK KR"/>
               </a:rPr>
               <a:t>실패의 세 층위</a:t>
             </a:r>
@@ -15455,7 +15455,7 @@
                 <a:solidFill>
                   <a:srgbClr val="1E293B"/>
                 </a:solidFill>
-                <a:latin typeface="맑은 고딕"/>
+                <a:latin typeface="Noto Sans CJK KR"/>
               </a:rPr>
               <a:t>① 언어 장벽</a:t>
             </a:r>
@@ -15467,7 +15467,7 @@
                 <a:solidFill>
                   <a:srgbClr val="1E293B"/>
                 </a:solidFill>
-                <a:latin typeface="맑은 고딕"/>
+                <a:latin typeface="Noto Sans CJK KR"/>
               </a:rPr>
               <a:t>    한국어 정규식 intent → 영어 질의 density ≈ 0</a:t>
             </a:r>
@@ -15479,7 +15479,7 @@
                 <a:solidFill>
                   <a:srgbClr val="1E293B"/>
                 </a:solidFill>
-                <a:latin typeface="맑은 고딕"/>
+                <a:latin typeface="Noto Sans CJK KR"/>
               </a:rPr>
               <a:t>    → 영어 intent 추가 시 R-DWA +38%, L-DWA +49%</a:t>
             </a:r>
@@ -15491,7 +15491,7 @@
                 <a:solidFill>
                   <a:srgbClr val="1E293B"/>
                 </a:solidFill>
-                <a:latin typeface="맑은 고딕"/>
+                <a:latin typeface="Noto Sans CJK KR"/>
               </a:rPr>
               <a:t/>
             </a:r>
@@ -15503,7 +15503,7 @@
                 <a:solidFill>
                   <a:srgbClr val="1E293B"/>
                 </a:solidFill>
-                <a:latin typeface="맑은 고딕"/>
+                <a:latin typeface="Noto Sans CJK KR"/>
               </a:rPr>
               <a:t>② 도메인 어휘</a:t>
             </a:r>
@@ -15515,7 +15515,7 @@
                 <a:solidFill>
                   <a:srgbClr val="1E293B"/>
                 </a:solidFill>
-                <a:latin typeface="맑은 고딕"/>
+                <a:latin typeface="Noto Sans CJK KR"/>
               </a:rPr>
               <a:t>    학습된 엔티티 vs HotpotQA 엔티티 상이</a:t>
             </a:r>
@@ -15527,7 +15527,7 @@
                 <a:solidFill>
                   <a:srgbClr val="1E293B"/>
                 </a:solidFill>
-                <a:latin typeface="맑은 고딕"/>
+                <a:latin typeface="Noto Sans CJK KR"/>
               </a:rPr>
               <a:t>    → 영어 합성 벤치마크 R-DWA 0.663</a:t>
             </a:r>
@@ -15539,7 +15539,7 @@
                 <a:solidFill>
                   <a:srgbClr val="1E293B"/>
                 </a:solidFill>
-                <a:latin typeface="맑은 고딕"/>
+                <a:latin typeface="Noto Sans CJK KR"/>
               </a:rPr>
               <a:t>       (한국어 0.529 보다 높음)</a:t>
             </a:r>
@@ -15551,7 +15551,7 @@
                 <a:solidFill>
                   <a:srgbClr val="1E293B"/>
                 </a:solidFill>
-                <a:latin typeface="맑은 고딕"/>
+                <a:latin typeface="Noto Sans CJK KR"/>
               </a:rPr>
               <a:t/>
             </a:r>
@@ -15563,7 +15563,7 @@
                 <a:solidFill>
                   <a:srgbClr val="1E293B"/>
                 </a:solidFill>
-                <a:latin typeface="맑은 고딕"/>
+                <a:latin typeface="Noto Sans CJK KR"/>
               </a:rPr>
               <a:t>③ Graph·Ontology 부재</a:t>
             </a:r>
@@ -15575,7 +15575,7 @@
                 <a:solidFill>
                   <a:srgbClr val="1E293B"/>
                 </a:solidFill>
-                <a:latin typeface="맑은 고딕"/>
+                <a:latin typeface="Noto Sans CJK KR"/>
               </a:rPr>
               <a:t>    HotpotQA 는 그래프 구조 없음</a:t>
             </a:r>
@@ -15587,7 +15587,7 @@
                 <a:solidFill>
                   <a:srgbClr val="1E293B"/>
                 </a:solidFill>
-                <a:latin typeface="맑은 고딕"/>
+                <a:latin typeface="Noto Sans CJK KR"/>
               </a:rPr>
               <a:t>    → 재학습 해도 곡선 평탄</a:t>
             </a:r>
@@ -15599,7 +15599,7 @@
                 <a:solidFill>
                   <a:srgbClr val="1E293B"/>
                 </a:solidFill>
-                <a:latin typeface="맑은 고딕"/>
+                <a:latin typeface="Noto Sans CJK KR"/>
               </a:rPr>
               <a:t>    = Triple-Hybrid 의 본질적 경계</a:t>
             </a:r>
@@ -15677,7 +15677,7 @@
                 <a:solidFill>
                   <a:srgbClr val="6B7280"/>
                 </a:solidFill>
-                <a:latin typeface="맑은 고딕"/>
+                <a:latin typeface="Noto Sans CJK KR"/>
               </a:rPr>
               <a:t>신동욱 (Shin Dong-wook) · 호서대학교 대학원 융합공학과 · 박사학위 방어 발표</a:t>
             </a:r>
@@ -15712,7 +15712,7 @@
                 <a:solidFill>
                   <a:srgbClr val="6B7280"/>
                 </a:solidFill>
-                <a:latin typeface="맑은 고딕"/>
+                <a:latin typeface="Noto Sans CJK KR"/>
               </a:rPr>
               <a:t>20 / 26</a:t>
             </a:r>
@@ -15747,7 +15747,7 @@
                 <a:solidFill>
                   <a:srgbClr val="1E3A8A"/>
                 </a:solidFill>
-                <a:latin typeface="맑은 고딕"/>
+                <a:latin typeface="Noto Sans CJK KR"/>
               </a:rPr>
               <a:t>Part C — 결과</a:t>
             </a:r>
@@ -15851,7 +15851,7 @@
                 <a:solidFill>
                   <a:srgbClr val="1E3A8A"/>
                 </a:solidFill>
-                <a:latin typeface="맑은 고딕"/>
+                <a:latin typeface="Noto Sans CJK KR"/>
               </a:rPr>
               <a:t>이 논문의 기여 네 가지</a:t>
             </a:r>
@@ -16007,7 +16007,7 @@
                 <a:solidFill>
                   <a:srgbClr val="1E3A8A"/>
                 </a:solidFill>
-                <a:latin typeface="맑은 고딕"/>
+                <a:latin typeface="Noto Sans CJK KR"/>
               </a:rPr>
               <a:t>방법론</a:t>
             </a:r>
@@ -16042,7 +16042,7 @@
                 <a:solidFill>
                   <a:srgbClr val="1E293B"/>
                 </a:solidFill>
-                <a:latin typeface="맑은 고딕"/>
+                <a:latin typeface="Noto Sans CJK KR"/>
               </a:rPr>
               <a:t>Triple-Hybrid RAG 의 가중치 결정을 1-step MDP 로 공식화하고 PPO 로 학습한 최초 사례</a:t>
             </a:r>
@@ -16120,7 +16120,7 @@
                 <a:solidFill>
                   <a:srgbClr val="4F86C6"/>
                 </a:solidFill>
-                <a:latin typeface="맑은 고딕"/>
+                <a:latin typeface="Noto Sans CJK KR"/>
               </a:rPr>
               <a:t>엔지니어링</a:t>
             </a:r>
@@ -16155,7 +16155,7 @@
                 <a:solidFill>
                   <a:srgbClr val="1E293B"/>
                 </a:solidFill>
-                <a:latin typeface="맑은 고딕"/>
+                <a:latin typeface="Noto Sans CJK KR"/>
               </a:rPr>
               <a:t>오프라인 보상 캐시 (330K, 16.8 MB) 로 학습 비용 $288 → $33 (−85%).</a:t>
             </a:r>
@@ -16167,7 +16167,7 @@
                 <a:solidFill>
                   <a:srgbClr val="1E293B"/>
                 </a:solidFill>
-                <a:latin typeface="맑은 고딕"/>
+                <a:latin typeface="Noto Sans CJK KR"/>
               </a:rPr>
               <a:t>RL-based RAG 튜닝을 개인 연구자 수준으로 접근 가능하게</a:t>
             </a:r>
@@ -16245,7 +16245,7 @@
                 <a:solidFill>
                   <a:srgbClr val="8FB573"/>
                 </a:solidFill>
-                <a:latin typeface="맑은 고딕"/>
+                <a:latin typeface="Noto Sans CJK KR"/>
               </a:rPr>
               <a:t>재현성</a:t>
             </a:r>
@@ -16280,7 +16280,7 @@
                 <a:solidFill>
                   <a:srgbClr val="1E293B"/>
                 </a:solidFill>
-                <a:latin typeface="맑은 고딕"/>
+                <a:latin typeface="Noto Sans CJK KR"/>
               </a:rPr>
               <a:t>선행 JKSCI 2025 의 평가 코드 결함 3건 발견 · 수정 · CORRIGENDUM 공개 정정</a:t>
             </a:r>
@@ -16292,7 +16292,7 @@
                 <a:solidFill>
                   <a:srgbClr val="1E293B"/>
                 </a:solidFill>
-                <a:latin typeface="맑은 고딕"/>
+                <a:latin typeface="Noto Sans CJK KR"/>
               </a:rPr>
               <a:t>(구두점 처리 · 프롬프트 형식 · Faithfulness 2-branch)</a:t>
             </a:r>
@@ -16370,7 +16370,7 @@
                 <a:solidFill>
                   <a:srgbClr val="E8756E"/>
                 </a:solidFill>
-                <a:latin typeface="맑은 고딕"/>
+                <a:latin typeface="Noto Sans CJK KR"/>
               </a:rPr>
               <a:t>실증</a:t>
             </a:r>
@@ -16405,7 +16405,7 @@
                 <a:solidFill>
                   <a:srgbClr val="1E293B"/>
                 </a:solidFill>
-                <a:latin typeface="맑은 고딕"/>
+                <a:latin typeface="Noto Sans CJK KR"/>
               </a:rPr>
               <a:t>L-DWA 가 R-DWA 대비 F1_strict +6.2%, 이산 Oracle 상한 0.554 를 0.562 로 초과.</a:t>
             </a:r>
@@ -16417,7 +16417,7 @@
                 <a:solidFill>
                   <a:srgbClr val="1E293B"/>
                 </a:solidFill>
-                <a:latin typeface="맑은 고딕"/>
+                <a:latin typeface="Noto Sans CJK KR"/>
               </a:rPr>
               <a:t>Conditional 유형에서 +36.7% 의 가장 큰 상대 개선.</a:t>
             </a:r>
@@ -16495,7 +16495,7 @@
                 <a:solidFill>
                   <a:srgbClr val="6B7280"/>
                 </a:solidFill>
-                <a:latin typeface="맑은 고딕"/>
+                <a:latin typeface="Noto Sans CJK KR"/>
               </a:rPr>
               <a:t>신동욱 (Shin Dong-wook) · 호서대학교 대학원 융합공학과 · 박사학위 방어 발표</a:t>
             </a:r>
@@ -16530,7 +16530,7 @@
                 <a:solidFill>
                   <a:srgbClr val="6B7280"/>
                 </a:solidFill>
-                <a:latin typeface="맑은 고딕"/>
+                <a:latin typeface="Noto Sans CJK KR"/>
               </a:rPr>
               <a:t>21 / 26</a:t>
             </a:r>
@@ -16565,7 +16565,7 @@
                 <a:solidFill>
                   <a:srgbClr val="1E3A8A"/>
                 </a:solidFill>
-                <a:latin typeface="맑은 고딕"/>
+                <a:latin typeface="Noto Sans CJK KR"/>
               </a:rPr>
               <a:t>Part D — 결론</a:t>
             </a:r>
@@ -16669,7 +16669,7 @@
                 <a:solidFill>
                   <a:srgbClr val="1E3A8A"/>
                 </a:solidFill>
-                <a:latin typeface="맑은 고딕"/>
+                <a:latin typeface="Noto Sans CJK KR"/>
               </a:rPr>
               <a:t>한계 및 향후 연구 방향</a:t>
             </a:r>
@@ -16782,7 +16782,7 @@
                 <a:solidFill>
                   <a:srgbClr val="E8756E"/>
                 </a:solidFill>
-                <a:latin typeface="맑은 고딕"/>
+                <a:latin typeface="Noto Sans CJK KR"/>
               </a:rPr>
               <a:t>솔직하게 보고하는 한계</a:t>
             </a:r>
@@ -16817,7 +16817,7 @@
                 <a:solidFill>
                   <a:srgbClr val="1E293B"/>
                 </a:solidFill>
-                <a:latin typeface="맑은 고딕"/>
+                <a:latin typeface="Noto Sans CJK KR"/>
               </a:rPr>
               <a:t>• 한국어 단일 도메인 end-to-end 학습</a:t>
             </a:r>
@@ -16829,7 +16829,7 @@
                 <a:solidFill>
                   <a:srgbClr val="1E293B"/>
                 </a:solidFill>
-                <a:latin typeface="맑은 고딕"/>
+                <a:latin typeface="Noto Sans CJK KR"/>
               </a:rPr>
               <a:t/>
             </a:r>
@@ -16841,7 +16841,7 @@
                 <a:solidFill>
                   <a:srgbClr val="1E293B"/>
                 </a:solidFill>
-                <a:latin typeface="맑은 고딕"/>
+                <a:latin typeface="Noto Sans CJK KR"/>
               </a:rPr>
               <a:t>• State 품질이 L-DWA 상한 결정</a:t>
             </a:r>
@@ -16853,7 +16853,7 @@
                 <a:solidFill>
                   <a:srgbClr val="1E293B"/>
                 </a:solidFill>
-                <a:latin typeface="맑은 고딕"/>
+                <a:latin typeface="Noto Sans CJK KR"/>
               </a:rPr>
               <a:t>    (영어 state 미구분 → R-DWA 수준)</a:t>
             </a:r>
@@ -16865,7 +16865,7 @@
                 <a:solidFill>
                   <a:srgbClr val="1E293B"/>
                 </a:solidFill>
-                <a:latin typeface="맑은 고딕"/>
+                <a:latin typeface="Noto Sans CJK KR"/>
               </a:rPr>
               <a:t/>
             </a:r>
@@ -16877,7 +16877,7 @@
                 <a:solidFill>
                   <a:srgbClr val="1E293B"/>
                 </a:solidFill>
-                <a:latin typeface="맑은 고딕"/>
+                <a:latin typeface="Noto Sans CJK KR"/>
               </a:rPr>
               <a:t>• EM 구조적 문제 — list prompt 로 0.39 회복</a:t>
             </a:r>
@@ -16889,7 +16889,7 @@
                 <a:solidFill>
                   <a:srgbClr val="1E293B"/>
                 </a:solidFill>
-                <a:latin typeface="맑은 고딕"/>
+                <a:latin typeface="Noto Sans CJK KR"/>
               </a:rPr>
               <a:t/>
             </a:r>
@@ -16901,7 +16901,7 @@
                 <a:solidFill>
                   <a:srgbClr val="1E293B"/>
                 </a:solidFill>
-                <a:latin typeface="맑은 고딕"/>
+                <a:latin typeface="Noto Sans CJK KR"/>
               </a:rPr>
               <a:t>• BERT intent classifier 미학습</a:t>
             </a:r>
@@ -16913,7 +16913,7 @@
                 <a:solidFill>
                   <a:srgbClr val="1E293B"/>
                 </a:solidFill>
-                <a:latin typeface="맑은 고딕"/>
+                <a:latin typeface="Noto Sans CJK KR"/>
               </a:rPr>
               <a:t/>
             </a:r>
@@ -16925,7 +16925,7 @@
                 <a:solidFill>
                   <a:srgbClr val="1E293B"/>
                 </a:solidFill>
-                <a:latin typeface="맑은 고딕"/>
+                <a:latin typeface="Noto Sans CJK KR"/>
               </a:rPr>
               <a:t>• 교차 도메인 naive transfer −30~35%</a:t>
             </a:r>
@@ -16960,7 +16960,7 @@
                 <a:solidFill>
                   <a:srgbClr val="1E3A8A"/>
                 </a:solidFill>
-                <a:latin typeface="맑은 고딕"/>
+                <a:latin typeface="Noto Sans CJK KR"/>
               </a:rPr>
               <a:t>향후 연구 방향</a:t>
             </a:r>
@@ -16995,7 +16995,7 @@
                 <a:solidFill>
                   <a:srgbClr val="1E293B"/>
                 </a:solidFill>
-                <a:latin typeface="맑은 고딕"/>
+                <a:latin typeface="Noto Sans CJK KR"/>
               </a:rPr>
               <a:t>• 다국어 state feature 설계</a:t>
             </a:r>
@@ -17007,7 +17007,7 @@
                 <a:solidFill>
                   <a:srgbClr val="1E293B"/>
                 </a:solidFill>
-                <a:latin typeface="맑은 고딕"/>
+                <a:latin typeface="Noto Sans CJK KR"/>
               </a:rPr>
               <a:t/>
             </a:r>
@@ -17019,7 +17019,7 @@
                 <a:solidFill>
                   <a:srgbClr val="1E293B"/>
                 </a:solidFill>
-                <a:latin typeface="맑은 고딕"/>
+                <a:latin typeface="Noto Sans CJK KR"/>
               </a:rPr>
               <a:t>• 도메인별 fine-tuning 레시피 체계화</a:t>
             </a:r>
@@ -17031,7 +17031,7 @@
                 <a:solidFill>
                   <a:srgbClr val="1E293B"/>
                 </a:solidFill>
-                <a:latin typeface="맑은 고딕"/>
+                <a:latin typeface="Noto Sans CJK KR"/>
               </a:rPr>
               <a:t/>
             </a:r>
@@ -17043,7 +17043,7 @@
                 <a:solidFill>
                   <a:srgbClr val="1E293B"/>
                 </a:solidFill>
-                <a:latin typeface="맑은 고딕"/>
+                <a:latin typeface="Noto Sans CJK KR"/>
               </a:rPr>
               <a:t>• Reward 재설계 (EM 가중치 재분배)</a:t>
             </a:r>
@@ -17055,7 +17055,7 @@
                 <a:solidFill>
                   <a:srgbClr val="1E293B"/>
                 </a:solidFill>
-                <a:latin typeface="맑은 고딕"/>
+                <a:latin typeface="Noto Sans CJK KR"/>
               </a:rPr>
               <a:t/>
             </a:r>
@@ -17067,7 +17067,7 @@
                 <a:solidFill>
                   <a:srgbClr val="1E293B"/>
                 </a:solidFill>
-                <a:latin typeface="맑은 고딕"/>
+                <a:latin typeface="Noto Sans CJK KR"/>
               </a:rPr>
               <a:t>• Joint multi-domain training</a:t>
             </a:r>
@@ -17079,7 +17079,7 @@
                 <a:solidFill>
                   <a:srgbClr val="1E293B"/>
                 </a:solidFill>
-                <a:latin typeface="맑은 고딕"/>
+                <a:latin typeface="Noto Sans CJK KR"/>
               </a:rPr>
               <a:t/>
             </a:r>
@@ -17091,7 +17091,7 @@
                 <a:solidFill>
                   <a:srgbClr val="1E293B"/>
                 </a:solidFill>
-                <a:latin typeface="맑은 고딕"/>
+                <a:latin typeface="Noto Sans CJK KR"/>
               </a:rPr>
               <a:t>• 더 큰 Actor-Critic 의 스케일링 효과</a:t>
             </a:r>
@@ -17103,7 +17103,7 @@
                 <a:solidFill>
                   <a:srgbClr val="1E293B"/>
                 </a:solidFill>
-                <a:latin typeface="맑은 고딕"/>
+                <a:latin typeface="Noto Sans CJK KR"/>
               </a:rPr>
               <a:t/>
             </a:r>
@@ -17115,7 +17115,7 @@
                 <a:solidFill>
                   <a:srgbClr val="1E293B"/>
                 </a:solidFill>
-                <a:latin typeface="맑은 고딕"/>
+                <a:latin typeface="Noto Sans CJK KR"/>
               </a:rPr>
               <a:t>• 선행 저장소와 평가기 통일</a:t>
             </a:r>
@@ -17193,7 +17193,7 @@
                 <a:solidFill>
                   <a:srgbClr val="6B7280"/>
                 </a:solidFill>
-                <a:latin typeface="맑은 고딕"/>
+                <a:latin typeface="Noto Sans CJK KR"/>
               </a:rPr>
               <a:t>신동욱 (Shin Dong-wook) · 호서대학교 대학원 융합공학과 · 박사학위 방어 발표</a:t>
             </a:r>
@@ -17228,7 +17228,7 @@
                 <a:solidFill>
                   <a:srgbClr val="6B7280"/>
                 </a:solidFill>
-                <a:latin typeface="맑은 고딕"/>
+                <a:latin typeface="Noto Sans CJK KR"/>
               </a:rPr>
               <a:t>22 / 26</a:t>
             </a:r>
@@ -17263,7 +17263,7 @@
                 <a:solidFill>
                   <a:srgbClr val="1E3A8A"/>
                 </a:solidFill>
-                <a:latin typeface="맑은 고딕"/>
+                <a:latin typeface="Noto Sans CJK KR"/>
               </a:rPr>
               <a:t>Part D — 결론</a:t>
             </a:r>
@@ -17367,7 +17367,7 @@
                 <a:solidFill>
                   <a:srgbClr val="1E3A8A"/>
                 </a:solidFill>
-                <a:latin typeface="맑은 고딕"/>
+                <a:latin typeface="Noto Sans CJK KR"/>
               </a:rPr>
               <a:t>연구 과정에서 얻은 두 교훈</a:t>
             </a:r>
@@ -17500,7 +17500,7 @@
                 <a:solidFill>
                   <a:srgbClr val="1E3A8A"/>
                 </a:solidFill>
-                <a:latin typeface="맑은 고딕"/>
+                <a:latin typeface="Noto Sans CJK KR"/>
               </a:rPr>
               <a:t>① 평가 코드를 다시 들여다본 경험</a:t>
             </a:r>
@@ -17512,7 +17512,7 @@
                 <a:solidFill>
                   <a:srgbClr val="1E293B"/>
                 </a:solidFill>
-                <a:latin typeface="맑은 고딕"/>
+                <a:latin typeface="Noto Sans CJK KR"/>
               </a:rPr>
               <a:t>마무리 단계에서 F1 수치가 기대보다 낮다는 인상을 받아 normalize_korean 을 역추적한 끝에, 쉼표와 마침표가 토큰화 이전에 제거되지 않는 작은 버그를 발견. 이를 바로잡고 나서야 L-DWA 의 Oracle 대비 위치가 제대로 드러남.  </a:t>
             </a:r>
@@ -17524,7 +17524,7 @@
                 <a:solidFill>
                   <a:srgbClr val="1E293B"/>
                 </a:solidFill>
-                <a:latin typeface="맑은 고딕"/>
+                <a:latin typeface="Noto Sans CJK KR"/>
               </a:rPr>
               <a:t>→ 실험 결과가 직관과 어긋날 때 평가 코드부터 다시 읽어 보는 습관의 중요성.</a:t>
             </a:r>
@@ -17579,7 +17579,7 @@
                 <a:solidFill>
                   <a:srgbClr val="8FB573"/>
                 </a:solidFill>
-                <a:latin typeface="맑은 고딕"/>
+                <a:latin typeface="Noto Sans CJK KR"/>
               </a:rPr>
               <a:t>② 기대와 다르게 나온 결과를 어떻게 다룰지</a:t>
             </a:r>
@@ -17591,7 +17591,7 @@
                 <a:solidFill>
                   <a:srgbClr val="1E293B"/>
                 </a:solidFill>
-                <a:latin typeface="맑은 고딕"/>
+                <a:latin typeface="Noto Sans CJK KR"/>
               </a:rPr>
               <a:t>교차 도메인 실험이 30~35% 저하로 나오자 한 문단 "한계" 로 넘기고 싶은 유혹이 있었음. 그러나 원인을 언어 · 도메인 · 아키텍처로 나누어 각각 별도 실험으로 확인해 보는 편이 오히려 더 명확한 결론을 냄.  </a:t>
             </a:r>
@@ -17603,7 +17603,7 @@
                 <a:solidFill>
                   <a:srgbClr val="1E293B"/>
                 </a:solidFill>
-                <a:latin typeface="맑은 고딕"/>
+                <a:latin typeface="Noto Sans CJK KR"/>
               </a:rPr>
               <a:t>→ 부정적 결과를 빨리 결론짓지 않는 쪽이 장기적으로 나은 서사를 만든다.</a:t>
             </a:r>
@@ -17681,7 +17681,7 @@
                 <a:solidFill>
                   <a:srgbClr val="6B7280"/>
                 </a:solidFill>
-                <a:latin typeface="맑은 고딕"/>
+                <a:latin typeface="Noto Sans CJK KR"/>
               </a:rPr>
               <a:t>신동욱 (Shin Dong-wook) · 호서대학교 대학원 융합공학과 · 박사학위 방어 발표</a:t>
             </a:r>
@@ -17716,7 +17716,7 @@
                 <a:solidFill>
                   <a:srgbClr val="6B7280"/>
                 </a:solidFill>
-                <a:latin typeface="맑은 고딕"/>
+                <a:latin typeface="Noto Sans CJK KR"/>
               </a:rPr>
               <a:t>23 / 26</a:t>
             </a:r>
@@ -17751,7 +17751,7 @@
                 <a:solidFill>
                   <a:srgbClr val="1E3A8A"/>
                 </a:solidFill>
-                <a:latin typeface="맑은 고딕"/>
+                <a:latin typeface="Noto Sans CJK KR"/>
               </a:rPr>
               <a:t>Part D — 결론</a:t>
             </a:r>
@@ -17855,7 +17855,7 @@
                 <a:solidFill>
                   <a:srgbClr val="FFFFFF"/>
                 </a:solidFill>
-                <a:latin typeface="맑은 고딕"/>
+                <a:latin typeface="Noto Sans CJK KR"/>
               </a:rPr>
               <a:t>감사합니다</a:t>
             </a:r>
@@ -17925,7 +17925,7 @@
                 <a:solidFill>
                   <a:srgbClr val="FFFFFF"/>
                 </a:solidFill>
-                <a:latin typeface="맑은 고딕"/>
+                <a:latin typeface="Noto Sans CJK KR"/>
               </a:rPr>
               <a:t>공개 자원</a:t>
             </a:r>
@@ -18112,7 +18112,7 @@
                 <a:solidFill>
                   <a:srgbClr val="1E3A8A"/>
                 </a:solidFill>
-                <a:latin typeface="맑은 고딕"/>
+                <a:latin typeface="Noto Sans CJK KR"/>
               </a:rPr>
               <a:t>Appendix A — PPO Hyperparameters</a:t>
             </a:r>
@@ -20188,7 +20188,7 @@
                 <a:solidFill>
                   <a:srgbClr val="6B7280"/>
                 </a:solidFill>
-                <a:latin typeface="맑은 고딕"/>
+                <a:latin typeface="Noto Sans CJK KR"/>
               </a:rPr>
               <a:t>신동욱 (Shin Dong-wook) · 호서대학교 대학원 융합공학과 · 박사학위 방어 발표</a:t>
             </a:r>
@@ -20223,7 +20223,7 @@
                 <a:solidFill>
                   <a:srgbClr val="6B7280"/>
                 </a:solidFill>
-                <a:latin typeface="맑은 고딕"/>
+                <a:latin typeface="Noto Sans CJK KR"/>
               </a:rPr>
               <a:t>25 / 26</a:t>
             </a:r>
@@ -20258,7 +20258,7 @@
                 <a:solidFill>
                   <a:srgbClr val="1E3A8A"/>
                 </a:solidFill>
-                <a:latin typeface="맑은 고딕"/>
+                <a:latin typeface="Noto Sans CJK KR"/>
               </a:rPr>
               <a:t>Appendix</a:t>
             </a:r>
@@ -20362,7 +20362,7 @@
                 <a:solidFill>
                   <a:srgbClr val="1E3A8A"/>
                 </a:solidFill>
-                <a:latin typeface="맑은 고딕"/>
+                <a:latin typeface="Noto Sans CJK KR"/>
               </a:rPr>
               <a:t>Appendix B — Case Studies CS-1 ~ CS-7 요약</a:t>
             </a:r>
@@ -20518,7 +20518,7 @@
                 <a:solidFill>
                   <a:srgbClr val="FFFFFF"/>
                 </a:solidFill>
-                <a:latin typeface="맑은 고딕"/>
+                <a:latin typeface="Noto Sans CJK KR"/>
               </a:rPr>
               <a:t>CS-1</a:t>
             </a:r>
@@ -20553,7 +20553,7 @@
                 <a:solidFill>
                   <a:srgbClr val="1E293B"/>
                 </a:solidFill>
-                <a:latin typeface="맑은 고딕"/>
+                <a:latin typeface="Noto Sans CJK KR"/>
               </a:rPr>
               <a:t>Simple 정책 수렴</a:t>
             </a:r>
@@ -20588,7 +20588,7 @@
                 <a:solidFill>
                   <a:srgbClr val="6B7280"/>
                 </a:solidFill>
-                <a:latin typeface="맑은 고딕"/>
+                <a:latin typeface="Noto Sans CJK KR"/>
               </a:rPr>
               <a:t>세 정책 모두 F1=1.0 (최재원 교수 소속 학과)</a:t>
             </a:r>
@@ -20666,7 +20666,7 @@
                 <a:solidFill>
                   <a:srgbClr val="FFFFFF"/>
                 </a:solidFill>
-                <a:latin typeface="맑은 고딕"/>
+                <a:latin typeface="Noto Sans CJK KR"/>
               </a:rPr>
               <a:t>CS-2</a:t>
             </a:r>
@@ -20701,7 +20701,7 @@
                 <a:solidFill>
                   <a:srgbClr val="1E293B"/>
                 </a:solidFill>
-                <a:latin typeface="맑은 고딕"/>
+                <a:latin typeface="Noto Sans CJK KR"/>
               </a:rPr>
               <a:t>Multi-hop 부분 회수</a:t>
             </a:r>
@@ -20736,7 +20736,7 @@
                 <a:solidFill>
                   <a:srgbClr val="6B7280"/>
                 </a:solidFill>
-                <a:latin typeface="맑은 고딕"/>
+                <a:latin typeface="Noto Sans CJK KR"/>
               </a:rPr>
               <a:t>R-DWA/L-DWA 동일 1/2 엔티티, Oracle 2/2</a:t>
             </a:r>
@@ -20814,7 +20814,7 @@
                 <a:solidFill>
                   <a:srgbClr val="FFFFFF"/>
                 </a:solidFill>
-                <a:latin typeface="맑은 고딕"/>
+                <a:latin typeface="Noto Sans CJK KR"/>
               </a:rPr>
               <a:t>CS-3</a:t>
             </a:r>
@@ -20849,7 +20849,7 @@
                 <a:solidFill>
                   <a:srgbClr val="1E293B"/>
                 </a:solidFill>
-                <a:latin typeface="맑은 고딕"/>
+                <a:latin typeface="Noto Sans CJK KR"/>
               </a:rPr>
               <a:t>Conditional 개선과 한계</a:t>
             </a:r>
@@ -20884,7 +20884,7 @@
                 <a:solidFill>
                   <a:srgbClr val="6B7280"/>
                 </a:solidFill>
-                <a:latin typeface="맑은 고딕"/>
+                <a:latin typeface="Noto Sans CJK KR"/>
               </a:rPr>
               <a:t>개별 실패지만 유형 집계 +36.7% (L-DWA &gt; Oracle)</a:t>
             </a:r>
@@ -20962,7 +20962,7 @@
                 <a:solidFill>
                   <a:srgbClr val="FFFFFF"/>
                 </a:solidFill>
-                <a:latin typeface="맑은 고딕"/>
+                <a:latin typeface="Noto Sans CJK KR"/>
               </a:rPr>
               <a:t>CS-4</a:t>
             </a:r>
@@ -20997,7 +20997,7 @@
                 <a:solidFill>
                   <a:srgbClr val="1E293B"/>
                 </a:solidFill>
-                <a:latin typeface="맑은 고딕"/>
+                <a:latin typeface="Noto Sans CJK KR"/>
               </a:rPr>
               <a:t>Faithfulness 2-branch</a:t>
             </a:r>
@@ -21032,7 +21032,7 @@
                 <a:solidFill>
                   <a:srgbClr val="6B7280"/>
                 </a:solidFill>
-                <a:latin typeface="맑은 고딕"/>
+                <a:latin typeface="Noto Sans CJK KR"/>
               </a:rPr>
               <a:t>Sentence 1.0 (과대) vs List 0.5 (환각 노출)</a:t>
             </a:r>
@@ -21110,7 +21110,7 @@
                 <a:solidFill>
                   <a:srgbClr val="FFFFFF"/>
                 </a:solidFill>
-                <a:latin typeface="맑은 고딕"/>
+                <a:latin typeface="Noto Sans CJK KR"/>
               </a:rPr>
               <a:t>CS-5</a:t>
             </a:r>
@@ -21145,7 +21145,7 @@
                 <a:solidFill>
                   <a:srgbClr val="1E293B"/>
                 </a:solidFill>
-                <a:latin typeface="맑은 고딕"/>
+                <a:latin typeface="Noto Sans CJK KR"/>
               </a:rPr>
               <a:t>Retrieval 한계</a:t>
             </a:r>
@@ -21180,7 +21180,7 @@
                 <a:solidFill>
                   <a:srgbClr val="6B7280"/>
                 </a:solidFill>
-                <a:latin typeface="맑은 고딕"/>
+                <a:latin typeface="Noto Sans CJK KR"/>
               </a:rPr>
               <a:t>Oracle 조차 12개 중 2개만 — 컨텍스트 상한</a:t>
             </a:r>
@@ -21258,7 +21258,7 @@
                 <a:solidFill>
                   <a:srgbClr val="FFFFFF"/>
                 </a:solidFill>
-                <a:latin typeface="맑은 고딕"/>
+                <a:latin typeface="Noto Sans CJK KR"/>
               </a:rPr>
               <a:t>CS-6</a:t>
             </a:r>
@@ -21293,7 +21293,7 @@
                 <a:solidFill>
                   <a:srgbClr val="1E293B"/>
                 </a:solidFill>
-                <a:latin typeface="맑은 고딕"/>
+                <a:latin typeface="Noto Sans CJK KR"/>
               </a:rPr>
               <a:t>교차 도메인 퇴행</a:t>
             </a:r>
@@ -21328,7 +21328,7 @@
                 <a:solidFill>
                   <a:srgbClr val="6B7280"/>
                 </a:solidFill>
-                <a:latin typeface="맑은 고딕"/>
+                <a:latin typeface="Noto Sans CJK KR"/>
               </a:rPr>
               <a:t>영어 질의 → density 0 → Vector-only 이하</a:t>
             </a:r>
@@ -21406,7 +21406,7 @@
                 <a:solidFill>
                   <a:srgbClr val="FFFFFF"/>
                 </a:solidFill>
-                <a:latin typeface="맑은 고딕"/>
+                <a:latin typeface="Noto Sans CJK KR"/>
               </a:rPr>
               <a:t>CS-7</a:t>
             </a:r>
@@ -21441,7 +21441,7 @@
                 <a:solidFill>
                   <a:srgbClr val="1E293B"/>
                 </a:solidFill>
-                <a:latin typeface="맑은 고딕"/>
+                <a:latin typeface="Noto Sans CJK KR"/>
               </a:rPr>
               <a:t>List 프롬프트 효과</a:t>
             </a:r>
@@ -21476,7 +21476,7 @@
                 <a:solidFill>
                   <a:srgbClr val="6B7280"/>
                 </a:solidFill>
-                <a:latin typeface="맑은 고딕"/>
+                <a:latin typeface="Noto Sans CJK KR"/>
               </a:rPr>
               <a:t>F1_strict 0.137 → 0.529 (×3.86), 평균 latency −50%</a:t>
             </a:r>
@@ -21554,7 +21554,7 @@
                 <a:solidFill>
                   <a:srgbClr val="6B7280"/>
                 </a:solidFill>
-                <a:latin typeface="맑은 고딕"/>
+                <a:latin typeface="Noto Sans CJK KR"/>
               </a:rPr>
               <a:t>신동욱 (Shin Dong-wook) · 호서대학교 대학원 융합공학과 · 박사학위 방어 발표</a:t>
             </a:r>
@@ -21589,7 +21589,7 @@
                 <a:solidFill>
                   <a:srgbClr val="6B7280"/>
                 </a:solidFill>
-                <a:latin typeface="맑은 고딕"/>
+                <a:latin typeface="Noto Sans CJK KR"/>
               </a:rPr>
               <a:t>26 / 26</a:t>
             </a:r>
@@ -21624,7 +21624,7 @@
                 <a:solidFill>
                   <a:srgbClr val="1E3A8A"/>
                 </a:solidFill>
-                <a:latin typeface="맑은 고딕"/>
+                <a:latin typeface="Noto Sans CJK KR"/>
               </a:rPr>
               <a:t>Appendix</a:t>
             </a:r>
@@ -21728,7 +21728,7 @@
                 <a:solidFill>
                   <a:srgbClr val="1E3A8A"/>
                 </a:solidFill>
-                <a:latin typeface="맑은 고딕"/>
+                <a:latin typeface="Noto Sans CJK KR"/>
               </a:rPr>
               <a:t>한 문장 요약</a:t>
             </a:r>
@@ -21841,7 +21841,7 @@
                 <a:solidFill>
                   <a:srgbClr val="1E3A8A"/>
                 </a:solidFill>
-                <a:latin typeface="맑은 고딕"/>
+                <a:latin typeface="Noto Sans CJK KR"/>
               </a:rPr>
               <a:t>Triple-Hybrid RAG 에서 Vector · Graph · Ontology 세 지식 소스의</a:t>
             </a:r>
@@ -21853,7 +21853,7 @@
                 <a:solidFill>
                   <a:srgbClr val="1E3A8A"/>
                 </a:solidFill>
-                <a:latin typeface="맑은 고딕"/>
+                <a:latin typeface="Noto Sans CJK KR"/>
               </a:rPr>
               <a:t>가중치 결정을 PPO 로 학습한 연속 정책 (L-DWA) 이 이산 격자 Oracle</a:t>
             </a:r>
@@ -21865,7 +21865,7 @@
                 <a:solidFill>
                   <a:srgbClr val="1E3A8A"/>
                 </a:solidFill>
-                <a:latin typeface="맑은 고딕"/>
+                <a:latin typeface="Noto Sans CJK KR"/>
               </a:rPr>
               <a:t>상한을 미세하게 초과하는 지점에 도달하였다.</a:t>
             </a:r>
@@ -21920,7 +21920,7 @@
                 <a:solidFill>
                   <a:srgbClr val="1E3A8A"/>
                 </a:solidFill>
-                <a:latin typeface="맑은 고딕"/>
+                <a:latin typeface="Noto Sans CJK KR"/>
               </a:rPr>
               <a:t>① Oracle 초과</a:t>
             </a:r>
@@ -21932,7 +21932,7 @@
                 <a:solidFill>
                   <a:srgbClr val="1E293B"/>
                 </a:solidFill>
-                <a:latin typeface="맑은 고딕"/>
+                <a:latin typeface="Noto Sans CJK KR"/>
               </a:rPr>
               <a:t>L-DWA 3-seed 평균 F1_strict 0.562</a:t>
             </a:r>
@@ -21944,7 +21944,7 @@
                 <a:solidFill>
                   <a:srgbClr val="1E293B"/>
                 </a:solidFill>
-                <a:latin typeface="맑은 고딕"/>
+                <a:latin typeface="Noto Sans CJK KR"/>
               </a:rPr>
               <a:t>&gt; 이산 격자 Oracle 0.554 (+0.8%p)</a:t>
             </a:r>
@@ -21956,7 +21956,7 @@
                 <a:solidFill>
                   <a:srgbClr val="1E293B"/>
                 </a:solidFill>
-                <a:latin typeface="맑은 고딕"/>
+                <a:latin typeface="Noto Sans CJK KR"/>
               </a:rPr>
               <a:t>네 개 F1 지표 모두에서 확인</a:t>
             </a:r>
@@ -21968,7 +21968,7 @@
                 <a:solidFill>
                   <a:srgbClr val="1E293B"/>
                 </a:solidFill>
-                <a:latin typeface="맑은 고딕"/>
+                <a:latin typeface="Noto Sans CJK KR"/>
               </a:rPr>
               <a:t>연속 Dirichlet 평균이 격자 바깥 활용</a:t>
             </a:r>
@@ -22023,7 +22023,7 @@
                 <a:solidFill>
                   <a:srgbClr val="E8756E"/>
                 </a:solidFill>
-                <a:latin typeface="맑은 고딕"/>
+                <a:latin typeface="Noto Sans CJK KR"/>
               </a:rPr>
               <a:t>② Conditional +36.7%</a:t>
             </a:r>
@@ -22035,7 +22035,7 @@
                 <a:solidFill>
                   <a:srgbClr val="1E293B"/>
                 </a:solidFill>
-                <a:latin typeface="맑은 고딕"/>
+                <a:latin typeface="Noto Sans CJK KR"/>
               </a:rPr>
               <a:t>조건부 질의 (n=1,250) 에서</a:t>
             </a:r>
@@ -22047,7 +22047,7 @@
                 <a:solidFill>
                   <a:srgbClr val="1E293B"/>
                 </a:solidFill>
-                <a:latin typeface="맑은 고딕"/>
+                <a:latin typeface="Noto Sans CJK KR"/>
               </a:rPr>
               <a:t>R-DWA 0.223 → L-DWA 0.304</a:t>
             </a:r>
@@ -22059,7 +22059,7 @@
                 <a:solidFill>
                   <a:srgbClr val="1E293B"/>
                 </a:solidFill>
-                <a:latin typeface="맑은 고딕"/>
+                <a:latin typeface="Noto Sans CJK KR"/>
               </a:rPr>
               <a:t>Oracle (0.290) 마저 초과</a:t>
             </a:r>
@@ -22071,7 +22071,7 @@
                 <a:solidFill>
                   <a:srgbClr val="1E293B"/>
                 </a:solidFill>
-                <a:latin typeface="맑은 고딕"/>
+                <a:latin typeface="Noto Sans CJK KR"/>
               </a:rPr>
               <a:t>유형 내 미세 구분을 학습이 포착</a:t>
             </a:r>
@@ -22126,7 +22126,7 @@
                 <a:solidFill>
                   <a:srgbClr val="8FB573"/>
                 </a:solidFill>
-                <a:latin typeface="맑은 고딕"/>
+                <a:latin typeface="Noto Sans CJK KR"/>
               </a:rPr>
               <a:t>③ 학습 비용 −85%</a:t>
             </a:r>
@@ -22138,7 +22138,7 @@
                 <a:solidFill>
                   <a:srgbClr val="1E293B"/>
                 </a:solidFill>
-                <a:latin typeface="맑은 고딕"/>
+                <a:latin typeface="Noto Sans CJK KR"/>
               </a:rPr>
               <a:t>오프라인 보상 캐시 (330K, 16.8MB)</a:t>
             </a:r>
@@ -22150,7 +22150,7 @@
                 <a:solidFill>
                   <a:srgbClr val="1E293B"/>
                 </a:solidFill>
-                <a:latin typeface="맑은 고딕"/>
+                <a:latin typeface="Noto Sans CJK KR"/>
               </a:rPr>
               <a:t>로 학습 중 LLM 호출 0 회</a:t>
             </a:r>
@@ -22162,7 +22162,7 @@
                 <a:solidFill>
                   <a:srgbClr val="1E293B"/>
                 </a:solidFill>
-                <a:latin typeface="맑은 고딕"/>
+                <a:latin typeface="Noto Sans CJK KR"/>
               </a:rPr>
               <a:t>$288 → $33 · 3-seed 5시간</a:t>
             </a:r>
@@ -22174,7 +22174,7 @@
                 <a:solidFill>
                   <a:srgbClr val="1E293B"/>
                 </a:solidFill>
-                <a:latin typeface="맑은 고딕"/>
+                <a:latin typeface="Noto Sans CJK KR"/>
               </a:rPr>
               <a:t>개인 연구자 수준 재현 가능</a:t>
             </a:r>
@@ -22252,7 +22252,7 @@
                 <a:solidFill>
                   <a:srgbClr val="6B7280"/>
                 </a:solidFill>
-                <a:latin typeface="맑은 고딕"/>
+                <a:latin typeface="Noto Sans CJK KR"/>
               </a:rPr>
               <a:t>신동욱 (Shin Dong-wook) · 호서대학교 대학원 융합공학과 · 박사학위 방어 발표</a:t>
             </a:r>
@@ -22287,7 +22287,7 @@
                 <a:solidFill>
                   <a:srgbClr val="6B7280"/>
                 </a:solidFill>
-                <a:latin typeface="맑은 고딕"/>
+                <a:latin typeface="Noto Sans CJK KR"/>
               </a:rPr>
               <a:t>3 / 26</a:t>
             </a:r>
@@ -22322,7 +22322,7 @@
                 <a:solidFill>
                   <a:srgbClr val="1E3A8A"/>
                 </a:solidFill>
-                <a:latin typeface="맑은 고딕"/>
+                <a:latin typeface="Noto Sans CJK KR"/>
               </a:rPr>
               <a:t>Part A — Opening</a:t>
             </a:r>
@@ -22426,7 +22426,7 @@
                 <a:solidFill>
                   <a:srgbClr val="1E3A8A"/>
                 </a:solidFill>
-                <a:latin typeface="맑은 고딕"/>
+                <a:latin typeface="Noto Sans CJK KR"/>
               </a:rPr>
               <a:t>배경 — RAG 란 무엇인가</a:t>
             </a:r>
@@ -22539,7 +22539,7 @@
                 <a:solidFill>
                   <a:srgbClr val="1E293B"/>
                 </a:solidFill>
-                <a:latin typeface="맑은 고딕"/>
+                <a:latin typeface="Noto Sans CJK KR"/>
               </a:rPr>
               <a:t>대형 언어모델 (LLM) 은 내부 지식만으로 답하면</a:t>
             </a:r>
@@ -22551,7 +22551,7 @@
                 <a:solidFill>
                   <a:srgbClr val="1E293B"/>
                 </a:solidFill>
-                <a:latin typeface="맑은 고딕"/>
+                <a:latin typeface="Noto Sans CJK KR"/>
               </a:rPr>
               <a:t>① 환각 (없는 사실을 지어냄),</a:t>
             </a:r>
@@ -22563,7 +22563,7 @@
                 <a:solidFill>
                   <a:srgbClr val="1E293B"/>
                 </a:solidFill>
-                <a:latin typeface="맑은 고딕"/>
+                <a:latin typeface="Noto Sans CJK KR"/>
               </a:rPr>
               <a:t>② 최신성 부족,</a:t>
             </a:r>
@@ -22575,7 +22575,7 @@
                 <a:solidFill>
                   <a:srgbClr val="1E293B"/>
                 </a:solidFill>
-                <a:latin typeface="맑은 고딕"/>
+                <a:latin typeface="Noto Sans CJK KR"/>
               </a:rPr>
               <a:t>③ 출처 불명 문제가 발생한다.</a:t>
             </a:r>
@@ -22587,7 +22587,7 @@
                 <a:solidFill>
                   <a:srgbClr val="1E293B"/>
                 </a:solidFill>
-                <a:latin typeface="맑은 고딕"/>
+                <a:latin typeface="Noto Sans CJK KR"/>
               </a:rPr>
               <a:t/>
             </a:r>
@@ -22599,7 +22599,7 @@
                 <a:solidFill>
                   <a:srgbClr val="1E293B"/>
                 </a:solidFill>
-                <a:latin typeface="맑은 고딕"/>
+                <a:latin typeface="Noto Sans CJK KR"/>
               </a:rPr>
               <a:t>RAG 는 답을 만들기 전에 먼저 관련 문서를 검색하여</a:t>
             </a:r>
@@ -22611,7 +22611,7 @@
                 <a:solidFill>
                   <a:srgbClr val="1E293B"/>
                 </a:solidFill>
-                <a:latin typeface="맑은 고딕"/>
+                <a:latin typeface="Noto Sans CJK KR"/>
               </a:rPr>
               <a:t>LLM 에 참고 맥락으로 제공하는 기법이다.</a:t>
             </a:r>
@@ -22666,7 +22666,7 @@
                 <a:solidFill>
                   <a:srgbClr val="1E3A8A"/>
                 </a:solidFill>
-                <a:latin typeface="맑은 고딕"/>
+                <a:latin typeface="Noto Sans CJK KR"/>
               </a:rPr>
               <a:t>① 질의 (Query)</a:t>
             </a:r>
@@ -22678,7 +22678,7 @@
                 <a:solidFill>
                   <a:srgbClr val="1E293B"/>
                 </a:solidFill>
-                <a:latin typeface="맑은 고딕"/>
+                <a:latin typeface="Noto Sans CJK KR"/>
               </a:rPr>
               <a:t>사용자 질문</a:t>
             </a:r>
@@ -22733,7 +22733,7 @@
                 <a:solidFill>
                   <a:srgbClr val="E8756E"/>
                 </a:solidFill>
-                <a:latin typeface="맑은 고딕"/>
+                <a:latin typeface="Noto Sans CJK KR"/>
               </a:rPr>
               <a:t>② Retrieval (검색)</a:t>
             </a:r>
@@ -22745,7 +22745,7 @@
                 <a:solidFill>
                   <a:srgbClr val="1E293B"/>
                 </a:solidFill>
-                <a:latin typeface="맑은 고딕"/>
+                <a:latin typeface="Noto Sans CJK KR"/>
               </a:rPr>
               <a:t>지식 소스에서 관련 정보 추출</a:t>
             </a:r>
@@ -22800,7 +22800,7 @@
                 <a:solidFill>
                   <a:srgbClr val="8FB573"/>
                 </a:solidFill>
-                <a:latin typeface="맑은 고딕"/>
+                <a:latin typeface="Noto Sans CJK KR"/>
               </a:rPr>
               <a:t>③ Generation (응답)</a:t>
             </a:r>
@@ -22812,7 +22812,7 @@
                 <a:solidFill>
                   <a:srgbClr val="1E293B"/>
                 </a:solidFill>
-                <a:latin typeface="맑은 고딕"/>
+                <a:latin typeface="Noto Sans CJK KR"/>
               </a:rPr>
               <a:t>LLM 이 맥락을 바탕으로 응답</a:t>
             </a:r>
@@ -22847,7 +22847,7 @@
                 <a:solidFill>
                   <a:srgbClr val="1E3A8A"/>
                 </a:solidFill>
-                <a:latin typeface="맑은 고딕"/>
+                <a:latin typeface="Noto Sans CJK KR"/>
               </a:rPr>
               <a:t>본 논문의 관심은 ② Retrieval 단계. 특히 Vector · Graph · Ontology</a:t>
             </a:r>
@@ -22859,7 +22859,7 @@
                 <a:solidFill>
                   <a:srgbClr val="1E3A8A"/>
                 </a:solidFill>
-                <a:latin typeface="맑은 고딕"/>
+                <a:latin typeface="Noto Sans CJK KR"/>
               </a:rPr>
               <a:t>세 이질적 소스를 동시에 사용하는 Triple-Hybrid 구조에서 각 소스의</a:t>
             </a:r>
@@ -22871,7 +22871,7 @@
                 <a:solidFill>
                   <a:srgbClr val="1E3A8A"/>
                 </a:solidFill>
-                <a:latin typeface="맑은 고딕"/>
+                <a:latin typeface="Noto Sans CJK KR"/>
               </a:rPr>
               <a:t>가중치 (α, β, γ) 를 어떻게 정할 것인가가 연구 질문이다.</a:t>
             </a:r>
@@ -22949,7 +22949,7 @@
                 <a:solidFill>
                   <a:srgbClr val="6B7280"/>
                 </a:solidFill>
-                <a:latin typeface="맑은 고딕"/>
+                <a:latin typeface="Noto Sans CJK KR"/>
               </a:rPr>
               <a:t>신동욱 (Shin Dong-wook) · 호서대학교 대학원 융합공학과 · 박사학위 방어 발표</a:t>
             </a:r>
@@ -22984,7 +22984,7 @@
                 <a:solidFill>
                   <a:srgbClr val="6B7280"/>
                 </a:solidFill>
-                <a:latin typeface="맑은 고딕"/>
+                <a:latin typeface="Noto Sans CJK KR"/>
               </a:rPr>
               <a:t>4 / 26</a:t>
             </a:r>
@@ -23019,7 +23019,7 @@
                 <a:solidFill>
                   <a:srgbClr val="1E3A8A"/>
                 </a:solidFill>
-                <a:latin typeface="맑은 고딕"/>
+                <a:latin typeface="Noto Sans CJK KR"/>
               </a:rPr>
               <a:t>Part B — 문제와 방법</a:t>
             </a:r>
@@ -23123,7 +23123,7 @@
                 <a:solidFill>
                   <a:srgbClr val="1E3A8A"/>
                 </a:solidFill>
-                <a:latin typeface="맑은 고딕"/>
+                <a:latin typeface="Noto Sans CJK KR"/>
               </a:rPr>
               <a:t>Triple-Hybrid — 세 지식 소스</a:t>
             </a:r>
@@ -23256,7 +23256,7 @@
                 <a:solidFill>
                   <a:srgbClr val="1E3A8A"/>
                 </a:solidFill>
-                <a:latin typeface="맑은 고딕"/>
+                <a:latin typeface="Noto Sans CJK KR"/>
               </a:rPr>
               <a:t>🔵 Vector 검색</a:t>
             </a:r>
@@ -23268,7 +23268,7 @@
                 <a:solidFill>
                   <a:srgbClr val="1E293B"/>
                 </a:solidFill>
-                <a:latin typeface="맑은 고딕"/>
+                <a:latin typeface="Noto Sans CJK KR"/>
               </a:rPr>
               <a:t>문장 임베딩 유사도</a:t>
             </a:r>
@@ -23280,7 +23280,7 @@
                 <a:solidFill>
                   <a:srgbClr val="1E293B"/>
                 </a:solidFill>
-                <a:latin typeface="맑은 고딕"/>
+                <a:latin typeface="Noto Sans CJK KR"/>
               </a:rPr>
               <a:t>FAISS, top-k=3</a:t>
             </a:r>
@@ -23292,7 +23292,7 @@
                 <a:solidFill>
                   <a:srgbClr val="1E293B"/>
                 </a:solidFill>
-                <a:latin typeface="맑은 고딕"/>
+                <a:latin typeface="Noto Sans CJK KR"/>
               </a:rPr>
               <a:t>강점:</a:t>
             </a:r>
@@ -23304,7 +23304,7 @@
                 <a:solidFill>
                   <a:srgbClr val="1E293B"/>
                 </a:solidFill>
-                <a:latin typeface="맑은 고딕"/>
+                <a:latin typeface="Noto Sans CJK KR"/>
               </a:rPr>
               <a:t>• 의미 기반 매칭</a:t>
             </a:r>
@@ -23316,7 +23316,7 @@
                 <a:solidFill>
                   <a:srgbClr val="1E293B"/>
                 </a:solidFill>
-                <a:latin typeface="맑은 고딕"/>
+                <a:latin typeface="Noto Sans CJK KR"/>
               </a:rPr>
               <a:t>• 어휘 변동에 유연</a:t>
             </a:r>
@@ -23328,7 +23328,7 @@
                 <a:solidFill>
                   <a:srgbClr val="1E293B"/>
                 </a:solidFill>
-                <a:latin typeface="맑은 고딕"/>
+                <a:latin typeface="Noto Sans CJK KR"/>
               </a:rPr>
               <a:t>약점:</a:t>
             </a:r>
@@ -23340,7 +23340,7 @@
                 <a:solidFill>
                   <a:srgbClr val="1E293B"/>
                 </a:solidFill>
-                <a:latin typeface="맑은 고딕"/>
+                <a:latin typeface="Noto Sans CJK KR"/>
               </a:rPr>
               <a:t>• 정확한 관계 추론 어려움</a:t>
             </a:r>
@@ -23395,7 +23395,7 @@
                 <a:solidFill>
                   <a:srgbClr val="8FB573"/>
                 </a:solidFill>
-                <a:latin typeface="맑은 고딕"/>
+                <a:latin typeface="Noto Sans CJK KR"/>
               </a:rPr>
               <a:t>🟢 Graph 검색</a:t>
             </a:r>
@@ -23407,7 +23407,7 @@
                 <a:solidFill>
                   <a:srgbClr val="1E293B"/>
                 </a:solidFill>
-                <a:latin typeface="맑은 고딕"/>
+                <a:latin typeface="Noto Sans CJK KR"/>
               </a:rPr>
               <a:t>엔티티-관계 BFS</a:t>
             </a:r>
@@ -23419,7 +23419,7 @@
                 <a:solidFill>
                   <a:srgbClr val="1E293B"/>
                 </a:solidFill>
-                <a:latin typeface="맑은 고딕"/>
+                <a:latin typeface="Noto Sans CJK KR"/>
               </a:rPr>
               <a:t>NetworkX, depth=3</a:t>
             </a:r>
@@ -23431,7 +23431,7 @@
                 <a:solidFill>
                   <a:srgbClr val="1E293B"/>
                 </a:solidFill>
-                <a:latin typeface="맑은 고딕"/>
+                <a:latin typeface="Noto Sans CJK KR"/>
               </a:rPr>
               <a:t>강점:</a:t>
             </a:r>
@@ -23443,7 +23443,7 @@
                 <a:solidFill>
                   <a:srgbClr val="1E293B"/>
                 </a:solidFill>
-                <a:latin typeface="맑은 고딕"/>
+                <a:latin typeface="Noto Sans CJK KR"/>
               </a:rPr>
               <a:t>• 멀티홉 관계 질의</a:t>
             </a:r>
@@ -23455,7 +23455,7 @@
                 <a:solidFill>
                   <a:srgbClr val="1E293B"/>
                 </a:solidFill>
-                <a:latin typeface="맑은 고딕"/>
+                <a:latin typeface="Noto Sans CJK KR"/>
               </a:rPr>
               <a:t>• 소속·참여 정보</a:t>
             </a:r>
@@ -23467,7 +23467,7 @@
                 <a:solidFill>
                   <a:srgbClr val="1E293B"/>
                 </a:solidFill>
-                <a:latin typeface="맑은 고딕"/>
+                <a:latin typeface="Noto Sans CJK KR"/>
               </a:rPr>
               <a:t>약점:</a:t>
             </a:r>
@@ -23479,7 +23479,7 @@
                 <a:solidFill>
                   <a:srgbClr val="1E293B"/>
                 </a:solidFill>
-                <a:latin typeface="맑은 고딕"/>
+                <a:latin typeface="Noto Sans CJK KR"/>
               </a:rPr>
               <a:t>• 유사 표현에 취약</a:t>
             </a:r>
@@ -23534,7 +23534,7 @@
                 <a:solidFill>
                   <a:srgbClr val="E8756E"/>
                 </a:solidFill>
-                <a:latin typeface="맑은 고딕"/>
+                <a:latin typeface="Noto Sans CJK KR"/>
               </a:rPr>
               <a:t>🔴 Ontology 추론</a:t>
             </a:r>
@@ -23546,7 +23546,7 @@
                 <a:solidFill>
                   <a:srgbClr val="1E293B"/>
                 </a:solidFill>
-                <a:latin typeface="맑은 고딕"/>
+                <a:latin typeface="Noto Sans CJK KR"/>
               </a:rPr>
               <a:t>Owlready2 + HermiT</a:t>
             </a:r>
@@ -23558,7 +23558,7 @@
                 <a:solidFill>
                   <a:srgbClr val="1E293B"/>
                 </a:solidFill>
-                <a:latin typeface="맑은 고딕"/>
+                <a:latin typeface="Noto Sans CJK KR"/>
               </a:rPr>
               <a:t>클래스·속성 추론</a:t>
             </a:r>
@@ -23570,7 +23570,7 @@
                 <a:solidFill>
                   <a:srgbClr val="1E293B"/>
                 </a:solidFill>
-                <a:latin typeface="맑은 고딕"/>
+                <a:latin typeface="Noto Sans CJK KR"/>
               </a:rPr>
               <a:t>강점:</a:t>
             </a:r>
@@ -23582,7 +23582,7 @@
                 <a:solidFill>
                   <a:srgbClr val="1E293B"/>
                 </a:solidFill>
-                <a:latin typeface="맑은 고딕"/>
+                <a:latin typeface="Noto Sans CJK KR"/>
               </a:rPr>
               <a:t>• 조건부 제약 (나이·자격)</a:t>
             </a:r>
@@ -23594,7 +23594,7 @@
                 <a:solidFill>
                   <a:srgbClr val="1E293B"/>
                 </a:solidFill>
-                <a:latin typeface="맑은 고딕"/>
+                <a:latin typeface="Noto Sans CJK KR"/>
               </a:rPr>
               <a:t>• 논리적 만족성</a:t>
             </a:r>
@@ -23606,7 +23606,7 @@
                 <a:solidFill>
                   <a:srgbClr val="1E293B"/>
                 </a:solidFill>
-                <a:latin typeface="맑은 고딕"/>
+                <a:latin typeface="Noto Sans CJK KR"/>
               </a:rPr>
               <a:t>약점:</a:t>
             </a:r>
@@ -23618,7 +23618,7 @@
                 <a:solidFill>
                   <a:srgbClr val="1E293B"/>
                 </a:solidFill>
-                <a:latin typeface="맑은 고딕"/>
+                <a:latin typeface="Noto Sans CJK KR"/>
               </a:rPr>
               <a:t>• 스키마에 의존</a:t>
             </a:r>
@@ -23653,7 +23653,7 @@
                 <a:solidFill>
                   <a:srgbClr val="1E3A8A"/>
                 </a:solidFill>
-                <a:latin typeface="맑은 고딕"/>
+                <a:latin typeface="Noto Sans CJK KR"/>
               </a:rPr>
               <a:t>세 소스는 서로 강점이 다름 → 질의마다 적절한 비율로 섞어야 함.</a:t>
             </a:r>
@@ -23731,7 +23731,7 @@
                 <a:solidFill>
                   <a:srgbClr val="6B7280"/>
                 </a:solidFill>
-                <a:latin typeface="맑은 고딕"/>
+                <a:latin typeface="Noto Sans CJK KR"/>
               </a:rPr>
               <a:t>신동욱 (Shin Dong-wook) · 호서대학교 대학원 융합공학과 · 박사학위 방어 발표</a:t>
             </a:r>
@@ -23766,7 +23766,7 @@
                 <a:solidFill>
                   <a:srgbClr val="6B7280"/>
                 </a:solidFill>
-                <a:latin typeface="맑은 고딕"/>
+                <a:latin typeface="Noto Sans CJK KR"/>
               </a:rPr>
               <a:t>5 / 26</a:t>
             </a:r>
@@ -23801,7 +23801,7 @@
                 <a:solidFill>
                   <a:srgbClr val="1E3A8A"/>
                 </a:solidFill>
-                <a:latin typeface="맑은 고딕"/>
+                <a:latin typeface="Noto Sans CJK KR"/>
               </a:rPr>
               <a:t>Part B — 문제와 방법</a:t>
             </a:r>
@@ -23905,7 +23905,7 @@
                 <a:solidFill>
                   <a:srgbClr val="1E3A8A"/>
                 </a:solidFill>
-                <a:latin typeface="맑은 고딕"/>
+                <a:latin typeface="Noto Sans CJK KR"/>
               </a:rPr>
               <a:t>α·β·γ — 가중치 문제</a:t>
             </a:r>
@@ -24018,7 +24018,7 @@
                 <a:solidFill>
                   <a:srgbClr val="1E293B"/>
                 </a:solidFill>
-                <a:latin typeface="맑은 고딕"/>
+                <a:latin typeface="Noto Sans CJK KR"/>
               </a:rPr>
               <a:t>세 소스의 기여도를 α·β·γ 로 표기, 합 = 1 제약</a:t>
             </a:r>
@@ -24053,7 +24053,7 @@
                 <a:solidFill>
                   <a:srgbClr val="1E293B"/>
                 </a:solidFill>
-                <a:latin typeface="맑은 고딕"/>
+                <a:latin typeface="Noto Sans CJK KR"/>
               </a:rPr>
               <a:t>→ (α, β, γ) 는 Δ³ 삼각형 안의 한 점</a:t>
             </a:r>
@@ -24065,7 +24065,7 @@
                 <a:solidFill>
                   <a:srgbClr val="1E293B"/>
                 </a:solidFill>
-                <a:latin typeface="맑은 고딕"/>
+                <a:latin typeface="Noto Sans CJK KR"/>
               </a:rPr>
               <a:t/>
             </a:r>
@@ -24077,7 +24077,7 @@
                 <a:solidFill>
                   <a:srgbClr val="1E293B"/>
                 </a:solidFill>
-                <a:latin typeface="맑은 고딕"/>
+                <a:latin typeface="Noto Sans CJK KR"/>
               </a:rPr>
               <a:t>예시:</a:t>
             </a:r>
@@ -24089,7 +24089,7 @@
                 <a:solidFill>
                   <a:srgbClr val="1E293B"/>
                 </a:solidFill>
-                <a:latin typeface="맑은 고딕"/>
+                <a:latin typeface="Noto Sans CJK KR"/>
               </a:rPr>
               <a:t>• (0.6, 0.2, 0.2) — Vector 중심</a:t>
             </a:r>
@@ -24101,7 +24101,7 @@
                 <a:solidFill>
                   <a:srgbClr val="1E293B"/>
                 </a:solidFill>
-                <a:latin typeface="맑은 고딕"/>
+                <a:latin typeface="Noto Sans CJK KR"/>
               </a:rPr>
               <a:t>• (0.2, 0.6, 0.2) — Graph 중심</a:t>
             </a:r>
@@ -24113,7 +24113,7 @@
                 <a:solidFill>
                   <a:srgbClr val="1E293B"/>
                 </a:solidFill>
-                <a:latin typeface="맑은 고딕"/>
+                <a:latin typeface="Noto Sans CJK KR"/>
               </a:rPr>
               <a:t>• (0.2, 0.2, 0.6) — Ontology 중심</a:t>
             </a:r>
@@ -24125,7 +24125,7 @@
                 <a:solidFill>
                   <a:srgbClr val="1E293B"/>
                 </a:solidFill>
-                <a:latin typeface="맑은 고딕"/>
+                <a:latin typeface="Noto Sans CJK KR"/>
               </a:rPr>
               <a:t>• (1/3, 1/3, 1/3) — 균등</a:t>
             </a:r>
@@ -24160,7 +24160,7 @@
                 <a:solidFill>
                   <a:srgbClr val="6B7280"/>
                 </a:solidFill>
-                <a:latin typeface="맑은 고딕"/>
+                <a:latin typeface="Noto Sans CJK KR"/>
               </a:rPr>
               <a:t>핵심 어려움 — 질의마다 최적의 점이 다름.  </a:t>
             </a:r>
@@ -24172,7 +24172,7 @@
                 <a:solidFill>
                   <a:srgbClr val="6B7280"/>
                 </a:solidFill>
-                <a:latin typeface="맑은 고딕"/>
+                <a:latin typeface="Noto Sans CJK KR"/>
               </a:rPr>
               <a:t>• 「최재원 교수의 소속 학과는?」 → Vector 중심  </a:t>
             </a:r>
@@ -24184,7 +24184,7 @@
                 <a:solidFill>
                   <a:srgbClr val="6B7280"/>
                 </a:solidFill>
-                <a:latin typeface="맑은 고딕"/>
+                <a:latin typeface="Noto Sans CJK KR"/>
               </a:rPr>
               <a:t>• 「55세 이하 소속 교수는?」 → Ontology 중심  </a:t>
             </a:r>
@@ -24196,7 +24196,7 @@
                 <a:solidFill>
                   <a:srgbClr val="6B7280"/>
                 </a:solidFill>
-                <a:latin typeface="맑은 고딕"/>
+                <a:latin typeface="Noto Sans CJK KR"/>
               </a:rPr>
               <a:t>• 「배 포함 프로젝트 참여 학과는?」 → Graph 중심</a:t>
             </a:r>
@@ -24274,7 +24274,7 @@
                 <a:solidFill>
                   <a:srgbClr val="6B7280"/>
                 </a:solidFill>
-                <a:latin typeface="맑은 고딕"/>
+                <a:latin typeface="Noto Sans CJK KR"/>
               </a:rPr>
               <a:t>신동욱 (Shin Dong-wook) · 호서대학교 대학원 융합공학과 · 박사학위 방어 발표</a:t>
             </a:r>
@@ -24309,7 +24309,7 @@
                 <a:solidFill>
                   <a:srgbClr val="6B7280"/>
                 </a:solidFill>
-                <a:latin typeface="맑은 고딕"/>
+                <a:latin typeface="Noto Sans CJK KR"/>
               </a:rPr>
               <a:t>6 / 26</a:t>
             </a:r>
@@ -24344,7 +24344,7 @@
                 <a:solidFill>
                   <a:srgbClr val="1E3A8A"/>
                 </a:solidFill>
-                <a:latin typeface="맑은 고딕"/>
+                <a:latin typeface="Noto Sans CJK KR"/>
               </a:rPr>
               <a:t>Part B — 문제와 방법</a:t>
             </a:r>
@@ -24448,7 +24448,7 @@
                 <a:solidFill>
                   <a:srgbClr val="1E3A8A"/>
                 </a:solidFill>
-                <a:latin typeface="맑은 고딕"/>
+                <a:latin typeface="Noto Sans CJK KR"/>
               </a:rPr>
               <a:t>선행 연구 — R-DWA (규칙 기반)</a:t>
             </a:r>
@@ -24561,7 +24561,7 @@
                 <a:solidFill>
                   <a:srgbClr val="1E3A8A"/>
                 </a:solidFill>
-                <a:latin typeface="맑은 고딕"/>
+                <a:latin typeface="Noto Sans CJK KR"/>
               </a:rPr>
               <a:t>Shin &amp; Moon (2025, JKSCI) — 2단계 규칙</a:t>
             </a:r>
@@ -24616,7 +24616,7 @@
                 <a:solidFill>
                   <a:srgbClr val="1E3A8A"/>
                 </a:solidFill>
-                <a:latin typeface="맑은 고딕"/>
+                <a:latin typeface="Noto Sans CJK KR"/>
               </a:rPr>
               <a:t>Stage 1-2. 유형별 기본 가중치 (Table 4-1)</a:t>
             </a:r>
@@ -24628,7 +24628,7 @@
                 <a:solidFill>
                   <a:srgbClr val="1E293B"/>
                 </a:solidFill>
-                <a:latin typeface="맑은 고딕"/>
+                <a:latin typeface="Noto Sans CJK KR"/>
               </a:rPr>
               <a:t>유형             α       β       γ</a:t>
             </a:r>
@@ -24640,7 +24640,7 @@
                 <a:solidFill>
                   <a:srgbClr val="1E293B"/>
                 </a:solidFill>
-                <a:latin typeface="맑은 고딕"/>
+                <a:latin typeface="Noto Sans CJK KR"/>
               </a:rPr>
               <a:t>simple           0.6     0.2     0.2</a:t>
             </a:r>
@@ -24652,7 +24652,7 @@
                 <a:solidFill>
                   <a:srgbClr val="1E293B"/>
                 </a:solidFill>
-                <a:latin typeface="맑은 고딕"/>
+                <a:latin typeface="Noto Sans CJK KR"/>
               </a:rPr>
               <a:t>multi_hop        0.2     0.6     0.2</a:t>
             </a:r>
@@ -24664,7 +24664,7 @@
                 <a:solidFill>
                   <a:srgbClr val="1E293B"/>
                 </a:solidFill>
-                <a:latin typeface="맑은 고딕"/>
+                <a:latin typeface="Noto Sans CJK KR"/>
               </a:rPr>
               <a:t>conditional      0.2     0.2     0.6</a:t>
             </a:r>
@@ -24676,7 +24676,7 @@
                 <a:solidFill>
                   <a:srgbClr val="1E293B"/>
                 </a:solidFill>
-                <a:latin typeface="맑은 고딕"/>
+                <a:latin typeface="Noto Sans CJK KR"/>
               </a:rPr>
               <a:t>+ 밀도 신호 s_r, s_c 로 미세 조정 (λ = 0.3)</a:t>
             </a:r>
@@ -24711,7 +24711,7 @@
                 <a:solidFill>
                   <a:srgbClr val="E8756E"/>
                 </a:solidFill>
-                <a:latin typeface="맑은 고딕"/>
+                <a:latin typeface="Noto Sans CJK KR"/>
               </a:rPr>
               <a:t>R-DWA 의 네 가지 구조적 한계</a:t>
             </a:r>
@@ -24746,7 +24746,7 @@
                 <a:solidFill>
                   <a:srgbClr val="1E293B"/>
                 </a:solidFill>
-                <a:latin typeface="맑은 고딕"/>
+                <a:latin typeface="Noto Sans CJK KR"/>
               </a:rPr>
               <a:t>① 도메인 편향된 기본 가중치</a:t>
             </a:r>
@@ -24758,7 +24758,7 @@
                 <a:solidFill>
                   <a:srgbClr val="1E293B"/>
                 </a:solidFill>
-                <a:latin typeface="맑은 고딕"/>
+                <a:latin typeface="Noto Sans CJK KR"/>
               </a:rPr>
               <a:t>    — Oracle 실측은 Ontology 지배적</a:t>
             </a:r>
@@ -24770,7 +24770,7 @@
                 <a:solidFill>
                   <a:srgbClr val="1E293B"/>
                 </a:solidFill>
-                <a:latin typeface="맑은 고딕"/>
+                <a:latin typeface="Noto Sans CJK KR"/>
               </a:rPr>
               <a:t/>
             </a:r>
@@ -24782,7 +24782,7 @@
                 <a:solidFill>
                   <a:srgbClr val="1E293B"/>
                 </a:solidFill>
-                <a:latin typeface="맑은 고딕"/>
+                <a:latin typeface="Noto Sans CJK KR"/>
               </a:rPr>
               <a:t>② 단일 λ = 0.3 하이퍼파라미터</a:t>
             </a:r>
@@ -24794,7 +24794,7 @@
                 <a:solidFill>
                   <a:srgbClr val="1E293B"/>
                 </a:solidFill>
-                <a:latin typeface="맑은 고딕"/>
+                <a:latin typeface="Noto Sans CJK KR"/>
               </a:rPr>
               <a:t>    — 질의별 특성 미반영</a:t>
             </a:r>
@@ -24806,7 +24806,7 @@
                 <a:solidFill>
                   <a:srgbClr val="1E293B"/>
                 </a:solidFill>
-                <a:latin typeface="맑은 고딕"/>
+                <a:latin typeface="Noto Sans CJK KR"/>
               </a:rPr>
               <a:t/>
             </a:r>
@@ -24818,7 +24818,7 @@
                 <a:solidFill>
                   <a:srgbClr val="1E293B"/>
                 </a:solidFill>
-                <a:latin typeface="맑은 고딕"/>
+                <a:latin typeface="Noto Sans CJK KR"/>
               </a:rPr>
               <a:t>③ 유형 내 미세 구분 부재</a:t>
             </a:r>
@@ -24830,7 +24830,7 @@
                 <a:solidFill>
                   <a:srgbClr val="1E293B"/>
                 </a:solidFill>
-                <a:latin typeface="맑은 고딕"/>
+                <a:latin typeface="Noto Sans CJK KR"/>
               </a:rPr>
               <a:t>    — 같은 conditional 도 성격 다양</a:t>
             </a:r>
@@ -24842,7 +24842,7 @@
                 <a:solidFill>
                   <a:srgbClr val="1E293B"/>
                 </a:solidFill>
-                <a:latin typeface="맑은 고딕"/>
+                <a:latin typeface="Noto Sans CJK KR"/>
               </a:rPr>
               <a:t/>
             </a:r>
@@ -24854,7 +24854,7 @@
                 <a:solidFill>
                   <a:srgbClr val="1E293B"/>
                 </a:solidFill>
-                <a:latin typeface="맑은 고딕"/>
+                <a:latin typeface="Noto Sans CJK KR"/>
               </a:rPr>
               <a:t>④ 도메인 이전 불가</a:t>
             </a:r>
@@ -24866,7 +24866,7 @@
                 <a:solidFill>
                   <a:srgbClr val="1E293B"/>
                 </a:solidFill>
-                <a:latin typeface="맑은 고딕"/>
+                <a:latin typeface="Noto Sans CJK KR"/>
               </a:rPr>
               <a:t>    — HotpotQA F1 0.097 &lt; Vector-only 0.102</a:t>
             </a:r>
@@ -24901,7 +24901,7 @@
                 <a:solidFill>
                   <a:srgbClr val="1E3A8A"/>
                 </a:solidFill>
-                <a:latin typeface="맑은 고딕"/>
+                <a:latin typeface="Noto Sans CJK KR"/>
               </a:rPr>
               <a:t>→ 본 논문은 이 네 한계를 정면으로 다루기 위해 규칙 표를 학습된 신경망으로 대체한다.</a:t>
             </a:r>
@@ -24979,7 +24979,7 @@
                 <a:solidFill>
                   <a:srgbClr val="6B7280"/>
                 </a:solidFill>
-                <a:latin typeface="맑은 고딕"/>
+                <a:latin typeface="Noto Sans CJK KR"/>
               </a:rPr>
               <a:t>신동욱 (Shin Dong-wook) · 호서대학교 대학원 융합공학과 · 박사학위 방어 발표</a:t>
             </a:r>
@@ -25014,7 +25014,7 @@
                 <a:solidFill>
                   <a:srgbClr val="6B7280"/>
                 </a:solidFill>
-                <a:latin typeface="맑은 고딕"/>
+                <a:latin typeface="Noto Sans CJK KR"/>
               </a:rPr>
               <a:t>7 / 26</a:t>
             </a:r>
@@ -25049,7 +25049,7 @@
                 <a:solidFill>
                   <a:srgbClr val="1E3A8A"/>
                 </a:solidFill>
-                <a:latin typeface="맑은 고딕"/>
+                <a:latin typeface="Noto Sans CJK KR"/>
               </a:rPr>
               <a:t>Part B — 문제와 방법</a:t>
             </a:r>
@@ -25153,7 +25153,7 @@
                 <a:solidFill>
                   <a:srgbClr val="1E3A8A"/>
                 </a:solidFill>
-                <a:latin typeface="맑은 고딕"/>
+                <a:latin typeface="Noto Sans CJK KR"/>
               </a:rPr>
               <a:t>제안 — L-DWA (MDP 공식화)</a:t>
             </a:r>
@@ -25266,7 +25266,7 @@
                 <a:solidFill>
                   <a:srgbClr val="1E3A8A"/>
                 </a:solidFill>
-                <a:latin typeface="맑은 고딕"/>
+                <a:latin typeface="Noto Sans CJK KR"/>
               </a:rPr>
               <a:t>가중치 결정을 Markov Decision Process 로 환원 — RAG 맥락에서 최초 사례</a:t>
             </a:r>
@@ -25321,7 +25321,7 @@
                 <a:solidFill>
                   <a:srgbClr val="1E3A8A"/>
                 </a:solidFill>
-                <a:latin typeface="맑은 고딕"/>
+                <a:latin typeface="Noto Sans CJK KR"/>
               </a:rPr>
               <a:t>🧩 State (18-dim)</a:t>
             </a:r>
@@ -25333,7 +25333,7 @@
                 <a:solidFill>
                   <a:srgbClr val="1E293B"/>
                 </a:solidFill>
-                <a:latin typeface="맑은 고딕"/>
+                <a:latin typeface="Noto Sans CJK KR"/>
               </a:rPr>
               <a:t>• 질의 메타 (길이·엔티티·제약)</a:t>
             </a:r>
@@ -25345,7 +25345,7 @@
                 <a:solidFill>
                   <a:srgbClr val="1E293B"/>
                 </a:solidFill>
-                <a:latin typeface="맑은 고딕"/>
+                <a:latin typeface="Noto Sans CJK KR"/>
               </a:rPr>
               <a:t>• Intent logits (3-dim)</a:t>
             </a:r>
@@ -25357,7 +25357,7 @@
                 <a:solidFill>
                   <a:srgbClr val="1E293B"/>
                 </a:solidFill>
-                <a:latin typeface="맑은 고딕"/>
+                <a:latin typeface="Noto Sans CJK KR"/>
               </a:rPr>
               <a:t>• 밀도 신호 (s_e, s_r, s_c)</a:t>
             </a:r>
@@ -25369,7 +25369,7 @@
                 <a:solidFill>
                   <a:srgbClr val="1E293B"/>
                 </a:solidFill>
-                <a:latin typeface="맑은 고딕"/>
+                <a:latin typeface="Noto Sans CJK KR"/>
               </a:rPr>
               <a:t>• Retrieval 점수 통계량</a:t>
             </a:r>
@@ -25424,7 +25424,7 @@
                 <a:solidFill>
                   <a:srgbClr val="E8756E"/>
                 </a:solidFill>
-                <a:latin typeface="맑은 고딕"/>
+                <a:latin typeface="Noto Sans CJK KR"/>
               </a:rPr>
               <a:t>🎯 Action (Δ³)</a:t>
             </a:r>
@@ -25436,7 +25436,7 @@
                 <a:solidFill>
                   <a:srgbClr val="1E293B"/>
                 </a:solidFill>
-                <a:latin typeface="맑은 고딕"/>
+                <a:latin typeface="Noto Sans CJK KR"/>
               </a:rPr>
               <a:t>• (α, β, γ) · 합 = 1</a:t>
             </a:r>
@@ -25448,7 +25448,7 @@
                 <a:solidFill>
                   <a:srgbClr val="1E293B"/>
                 </a:solidFill>
-                <a:latin typeface="맑은 고딕"/>
+                <a:latin typeface="Noto Sans CJK KR"/>
               </a:rPr>
               <a:t>• 연속 simplex</a:t>
             </a:r>
@@ -25460,7 +25460,7 @@
                 <a:solidFill>
                   <a:srgbClr val="1E293B"/>
                 </a:solidFill>
-                <a:latin typeface="맑은 고딕"/>
+                <a:latin typeface="Noto Sans CJK KR"/>
               </a:rPr>
               <a:t>• Dirichlet 분포에서 샘플링</a:t>
             </a:r>
@@ -25515,7 +25515,7 @@
                 <a:solidFill>
                   <a:srgbClr val="8FB573"/>
                 </a:solidFill>
-                <a:latin typeface="맑은 고딕"/>
+                <a:latin typeface="Noto Sans CJK KR"/>
               </a:rPr>
               <a:t>💰 Reward (scalar)</a:t>
             </a:r>
@@ -25527,7 +25527,7 @@
                 <a:solidFill>
                   <a:srgbClr val="1E293B"/>
                 </a:solidFill>
-                <a:latin typeface="맑은 고딕"/>
+                <a:latin typeface="Noto Sans CJK KR"/>
               </a:rPr>
               <a:t>R = 0.5·F1 + 0.3·EM</a:t>
             </a:r>
@@ -25539,7 +25539,7 @@
                 <a:solidFill>
                   <a:srgbClr val="1E293B"/>
                 </a:solidFill>
-                <a:latin typeface="맑은 고딕"/>
+                <a:latin typeface="Noto Sans CJK KR"/>
               </a:rPr>
               <a:t>      + 0.2·Faith</a:t>
             </a:r>
@@ -25551,7 +25551,7 @@
                 <a:solidFill>
                   <a:srgbClr val="1E293B"/>
                 </a:solidFill>
-                <a:latin typeface="맑은 고딕"/>
+                <a:latin typeface="Noto Sans CJK KR"/>
               </a:rPr>
               <a:t>      − 0.1·max(0, latency−5)</a:t>
             </a:r>
@@ -25586,7 +25586,7 @@
                 <a:solidFill>
                   <a:srgbClr val="1E293B"/>
                 </a:solidFill>
-                <a:latin typeface="맑은 고딕"/>
+                <a:latin typeface="Noto Sans CJK KR"/>
               </a:rPr>
               <a:t>에피소드 길이 = 1 — 가중치를 한 번 내면 retrieval·generation 이 일어나고</a:t>
             </a:r>
@@ -25598,7 +25598,7 @@
                 <a:solidFill>
                   <a:srgbClr val="1E293B"/>
                 </a:solidFill>
-                <a:latin typeface="맑은 고딕"/>
+                <a:latin typeface="Noto Sans CJK KR"/>
               </a:rPr>
               <a:t>즉시 보상이 결정되므로 다단계 transition 이 없음. 이 단순화가 학습을</a:t>
             </a:r>
@@ -25610,7 +25610,7 @@
                 <a:solidFill>
                   <a:srgbClr val="1E293B"/>
                 </a:solidFill>
-                <a:latin typeface="맑은 고딕"/>
+                <a:latin typeface="Noto Sans CJK KR"/>
               </a:rPr>
               <a:t>극히 안정적으로 만들고, 오프라인 보상 캐시 아이디어의 전제가 됨.</a:t>
             </a:r>
@@ -25688,7 +25688,7 @@
                 <a:solidFill>
                   <a:srgbClr val="6B7280"/>
                 </a:solidFill>
-                <a:latin typeface="맑은 고딕"/>
+                <a:latin typeface="Noto Sans CJK KR"/>
               </a:rPr>
               <a:t>신동욱 (Shin Dong-wook) · 호서대학교 대학원 융합공학과 · 박사학위 방어 발표</a:t>
             </a:r>
@@ -25723,7 +25723,7 @@
                 <a:solidFill>
                   <a:srgbClr val="6B7280"/>
                 </a:solidFill>
-                <a:latin typeface="맑은 고딕"/>
+                <a:latin typeface="Noto Sans CJK KR"/>
               </a:rPr>
               <a:t>8 / 26</a:t>
             </a:r>
@@ -25758,7 +25758,7 @@
                 <a:solidFill>
                   <a:srgbClr val="1E3A8A"/>
                 </a:solidFill>
-                <a:latin typeface="맑은 고딕"/>
+                <a:latin typeface="Noto Sans CJK KR"/>
               </a:rPr>
               <a:t>Part B — 문제와 방법</a:t>
             </a:r>
@@ -25862,7 +25862,7 @@
                 <a:solidFill>
                   <a:srgbClr val="1E3A8A"/>
                 </a:solidFill>
-                <a:latin typeface="맑은 고딕"/>
+                <a:latin typeface="Noto Sans CJK KR"/>
               </a:rPr>
               <a:t>신경망 구조 — Actor-Critic</a:t>
             </a:r>
@@ -25975,7 +25975,7 @@
                 <a:solidFill>
                   <a:srgbClr val="1E3A8A"/>
                 </a:solidFill>
-                <a:latin typeface="맑은 고딕"/>
+                <a:latin typeface="Noto Sans CJK KR"/>
               </a:rPr>
               <a:t>구성 요소</a:t>
             </a:r>
@@ -26010,7 +26010,7 @@
                 <a:solidFill>
                   <a:srgbClr val="1E293B"/>
                 </a:solidFill>
-                <a:latin typeface="맑은 고딕"/>
+                <a:latin typeface="Noto Sans CJK KR"/>
               </a:rPr>
               <a:t>공유 백본:</a:t>
             </a:r>
@@ -26022,7 +26022,7 @@
                 <a:solidFill>
                   <a:srgbClr val="1E293B"/>
                 </a:solidFill>
-                <a:latin typeface="맑은 고딕"/>
+                <a:latin typeface="Noto Sans CJK KR"/>
               </a:rPr>
               <a:t>  18 → 64 → 64 (Tanh)</a:t>
             </a:r>
@@ -26034,7 +26034,7 @@
                 <a:solidFill>
                   <a:srgbClr val="1E293B"/>
                 </a:solidFill>
-                <a:latin typeface="맑은 고딕"/>
+                <a:latin typeface="Noto Sans CJK KR"/>
               </a:rPr>
               <a:t/>
             </a:r>
@@ -26046,7 +26046,7 @@
                 <a:solidFill>
                   <a:srgbClr val="1E293B"/>
                 </a:solidFill>
-                <a:latin typeface="맑은 고딕"/>
+                <a:latin typeface="Noto Sans CJK KR"/>
               </a:rPr>
               <a:t>Actor head:</a:t>
             </a:r>
@@ -26058,7 +26058,7 @@
                 <a:solidFill>
                   <a:srgbClr val="1E293B"/>
                 </a:solidFill>
-                <a:latin typeface="맑은 고딕"/>
+                <a:latin typeface="Noto Sans CJK KR"/>
               </a:rPr>
               <a:t>  64 → 3 (Dirichlet α_i)</a:t>
             </a:r>
@@ -26070,7 +26070,7 @@
                 <a:solidFill>
                   <a:srgbClr val="1E293B"/>
                 </a:solidFill>
-                <a:latin typeface="맑은 고딕"/>
+                <a:latin typeface="Noto Sans CJK KR"/>
               </a:rPr>
               <a:t/>
             </a:r>
@@ -26082,7 +26082,7 @@
                 <a:solidFill>
                   <a:srgbClr val="1E293B"/>
                 </a:solidFill>
-                <a:latin typeface="맑은 고딕"/>
+                <a:latin typeface="Noto Sans CJK KR"/>
               </a:rPr>
               <a:t>Critic head:</a:t>
             </a:r>
@@ -26094,7 +26094,7 @@
                 <a:solidFill>
                   <a:srgbClr val="1E293B"/>
                 </a:solidFill>
-                <a:latin typeface="맑은 고딕"/>
+                <a:latin typeface="Noto Sans CJK KR"/>
               </a:rPr>
               <a:t>  64 → 1 (V(s))</a:t>
             </a:r>
@@ -26106,7 +26106,7 @@
                 <a:solidFill>
                   <a:srgbClr val="1E293B"/>
                 </a:solidFill>
-                <a:latin typeface="맑은 고딕"/>
+                <a:latin typeface="Noto Sans CJK KR"/>
               </a:rPr>
               <a:t/>
             </a:r>
@@ -26118,7 +26118,7 @@
                 <a:solidFill>
                   <a:srgbClr val="1E293B"/>
                 </a:solidFill>
-                <a:latin typeface="맑은 고딕"/>
+                <a:latin typeface="Noto Sans CJK KR"/>
               </a:rPr>
               <a:t>총 파라미터 = 5,636</a:t>
             </a:r>
@@ -26130,7 +26130,7 @@
                 <a:solidFill>
                   <a:srgbClr val="1E293B"/>
                 </a:solidFill>
-                <a:latin typeface="맑은 고딕"/>
+                <a:latin typeface="Noto Sans CJK KR"/>
               </a:rPr>
               <a:t>(스마트폰 수준)</a:t>
             </a:r>
@@ -26208,7 +26208,7 @@
                 <a:solidFill>
                   <a:srgbClr val="6B7280"/>
                 </a:solidFill>
-                <a:latin typeface="맑은 고딕"/>
+                <a:latin typeface="Noto Sans CJK KR"/>
               </a:rPr>
               <a:t>신동욱 (Shin Dong-wook) · 호서대학교 대학원 융합공학과 · 박사학위 방어 발표</a:t>
             </a:r>
@@ -26243,7 +26243,7 @@
                 <a:solidFill>
                   <a:srgbClr val="6B7280"/>
                 </a:solidFill>
-                <a:latin typeface="맑은 고딕"/>
+                <a:latin typeface="Noto Sans CJK KR"/>
               </a:rPr>
               <a:t>9 / 26</a:t>
             </a:r>
@@ -26278,7 +26278,7 @@
                 <a:solidFill>
                   <a:srgbClr val="1E3A8A"/>
                 </a:solidFill>
-                <a:latin typeface="맑은 고딕"/>
+                <a:latin typeface="Noto Sans CJK KR"/>
               </a:rPr>
               <a:t>Part B — 문제와 방법</a:t>
             </a:r>

</xml_diff>